<commit_message>
Deck: spaza segment R180bn, matching the sources file and the submitted background
Co-Authored-By: Claude Opus 5.5 <noreply@anthropic.com>
Claude-Session: https://claude.ai/code/session_01W9vcEkUR51B1hgQFTnjcUh
</commit_message>
<xml_diff>
--- a/docs/submission/05_final_submission/Akayza_Pitch_TeamPR.pptx
+++ b/docs/submission/05_final_submission/Akayza_Pitch_TeamPR.pptx
@@ -2874,8 +2874,8 @@
           <a:p>
             <a:r>
               <a:rPr lang="en-US" dirty="0"/>
-              <a:t>SAY (20 s): 'The whole township economy is R900 billion. Spaza shops alone spend about R150 billion in cash a year with their suppliers: one segment, already buying every week. Our goal is 20,000 businesses and 200 paying suppliers by year three, about R13 million a year.'
-R150 bn is specifically spaza shops (that's what the evidence measures), so we name them here. Everywhere else: informal and small businesses.</a:t>
+              <a:t>SAY (20 s): 'The whole township economy is R900 billion. Spaza shops alone move about R180 billion a year: one segment, already buying every week. Our goal is 20,000 businesses and 200 paying suppliers by year three, about R13 million a year.'
+R180 bn is specifically spaza shops (that's what the evidence measures), so we name them here. Everywhere else: informal and small businesses.</a:t>
             </a:r>
             <a:endParaRPr lang="en-US" dirty="0"/>
           </a:p>
@@ -19145,7 +19145,7 @@
                 <a:ea typeface="Georgia" pitchFamily="34" charset="-122"/>
                 <a:cs typeface="Georgia" pitchFamily="34" charset="-120"/>
               </a:rPr>
-              <a:t>R150 bn</a:t>
+              <a:t>R180 bn</a:t>
             </a:r>
             <a:endParaRPr lang="en-US" sz="2000" dirty="0"/>
           </a:p>
@@ -19301,7 +19301,7 @@
                 <a:ea typeface="Georgia" pitchFamily="34" charset="-122"/>
                 <a:cs typeface="Georgia" pitchFamily="34" charset="-120"/>
               </a:rPr>
-              <a:t>R150 bn</a:t>
+              <a:t>R180 bn</a:t>
             </a:r>
             <a:endParaRPr lang="en-US" sz="2800" dirty="0"/>
           </a:p>
@@ -19340,7 +19340,7 @@
                 <a:ea typeface="Calibri" pitchFamily="34" charset="-122"/>
                 <a:cs typeface="Calibri" pitchFamily="34" charset="-120"/>
               </a:rPr>
-              <a:t>Spent in cash at about 150,000 spaza shops alone: one segment, already buying from suppliers every week.</a:t>
+              <a:t>Moves through spaza shops alone every year: one segment, already buying from suppliers every week.</a:t>
             </a:r>
             <a:endParaRPr lang="en-US" sz="1600" dirty="0"/>
           </a:p>
@@ -19520,7 +19520,7 @@
                 <a:ea typeface="Calibri" pitchFamily="34" charset="-122"/>
                 <a:cs typeface="Calibri" pitchFamily="34" charset="-120"/>
               </a:rPr>
-              <a:t>Standard Bank 2025 (economy size; ~R150 bn cash spend at spaza shops, reported with the report's launch). Year-3 figures are our estimates.</a:t>
+              <a:t>Standard Bank 2025 (economy size; spaza segment ~R180 bn a year). Year-3 figures are our estimates.</a:t>
             </a:r>
             <a:endParaRPr lang="en-US" sz="950" dirty="0"/>
           </a:p>

</xml_diff>

<commit_message>
Deck: post-quantum sealed records are built (ML-DSA-65 + Ed25519), not just planned
Co-Authored-By: Claude Opus 5.5 <noreply@anthropic.com>
Claude-Session: https://claude.ai/code/session_01W9vcEkUR51B1hgQFTnjcUh
</commit_message>
<xml_diff>
--- a/docs/submission/05_final_submission/Akayza_Pitch_TeamPR.pptx
+++ b/docs/submission/05_final_submission/Akayza_Pitch_TeamPR.pptx
@@ -2341,7 +2341,7 @@
           <a:p>
             <a:r>
               <a:rPr lang="en-US" dirty="0"/>
-              <a:t>Post-quantum outline (bonus points for outlining it): 'Records and invoices are meant to prove things for years. Quantum computers will break today's signatures, so we'll sign with ML-DSA, the NIST post-quantum standard.' Say clearly it's planned, not built.</a:t>
+              <a:t>Post-quantum (built): 'Records are meant to prove things for years, and quantum computers will break today's signatures. So the owner can seal their whole record with two signatures: ML-DSA-65, the NIST post-quantum standard, and Ed25519. A check shows exactly which records changed or were deleted, even straight in the database. We keep no copy of the seal, and our public keys are published so anyone can check without us.' Built and tested; invoices and receipts are next.</a:t>
             </a:r>
             <a:endParaRPr lang="en-US" dirty="0"/>
           </a:p>
@@ -14208,7 +14208,7 @@
                 <a:ea typeface="Georgia" pitchFamily="34" charset="-122"/>
                 <a:cs typeface="Georgia" pitchFamily="34" charset="-120"/>
               </a:rPr>
-              <a:t>Post-quantum</a:t>
+              <a:t>Quantum-safe</a:t>
             </a:r>
             <a:endParaRPr lang="en-US" sz="2200" dirty="0"/>
           </a:p>
@@ -14251,7 +14251,7 @@
                 <a:ea typeface="Calibri" pitchFamily="34" charset="-122"/>
                 <a:cs typeface="Calibri" pitchFamily="34" charset="-120"/>
               </a:rPr>
-              <a:t>Sign records and invoices with ML-DSA (NIST FIPS 204)</a:t>
+              <a:t>Built: the owner seals their record with ML-DSA-65 (NIST FIPS 204) plus Ed25519</a:t>
             </a:r>
             <a:endParaRPr lang="en-US" sz="1550" dirty="0"/>
           </a:p>
@@ -14272,7 +14272,7 @@
                 <a:ea typeface="Calibri" pitchFamily="34" charset="-122"/>
                 <a:cs typeface="Calibri" pitchFamily="34" charset="-120"/>
               </a:rPr>
-              <a:t>So a record signed today still proves itself in 20 years</a:t>
+              <a:t>A check shows any record changed or deleted</a:t>
             </a:r>
             <a:endParaRPr lang="en-US" sz="1550" dirty="0"/>
           </a:p>
@@ -14293,7 +14293,7 @@
                 <a:ea typeface="Calibri" pitchFamily="34" charset="-122"/>
                 <a:cs typeface="Calibri" pitchFamily="34" charset="-120"/>
               </a:rPr>
-              <a:t>Planned, not built yet</a:t>
+              <a:t>Next: invoices and receipts too</a:t>
             </a:r>
             <a:endParaRPr lang="en-US" sz="1550" dirty="0"/>
           </a:p>

</xml_diff>

<commit_message>
Deck: test counts after the sealed-records merge (1,281 backend, 204 app)
Co-Authored-By: Claude Opus 5.5 <noreply@anthropic.com>
Claude-Session: https://claude.ai/code/session_01W9vcEkUR51B1hgQFTnjcUh
</commit_message>
<xml_diff>
--- a/docs/submission/05_final_submission/Akayza_Pitch_TeamPR.pptx
+++ b/docs/submission/05_final_submission/Akayza_Pitch_TeamPR.pptx
@@ -8752,7 +8752,7 @@
                 <a:ea typeface="Georgia" pitchFamily="34" charset="-122"/>
                 <a:cs typeface="Georgia" pitchFamily="34" charset="-120"/>
               </a:rPr>
-              <a:t>1,239</a:t>
+              <a:t>1,281</a:t>
             </a:r>
             <a:endParaRPr lang="en-US" sz="4400" dirty="0"/>
           </a:p>
@@ -8857,7 +8857,7 @@
                 <a:ea typeface="Georgia" pitchFamily="34" charset="-122"/>
                 <a:cs typeface="Georgia" pitchFamily="34" charset="-120"/>
               </a:rPr>
-              <a:t>197</a:t>
+              <a:t>204</a:t>
             </a:r>
             <a:endParaRPr lang="en-US" sz="4400" dirty="0"/>
           </a:p>

</xml_diff>

<commit_message>
Speech and slide 2: banks and payment apps instead of the building-site line
Risuna dropped "On some building sites, groups demand a cut of the work".
The new line keeps the angle, needs no number, and sets up "Payment
apps take cards" later in the speech.

Co-Authored-By: Claude Opus 5.5 <noreply@anthropic.com>
</commit_message>
<xml_diff>
--- a/docs/submission/05_final_submission/Akayza_Pitch_TeamPR.pptx
+++ b/docs/submission/05_final_submission/Akayza_Pitch_TeamPR.pptx
@@ -131,7 +131,7 @@
   <p:extLst>
     <p:ext uri="{521415D9-36F7-43E2-AB2F-B90AF26B5E84}">
       <p14:sectionLst xmlns:p14="http://schemas.microsoft.com/office/powerpoint/2010/main">
-        <p14:section name="3-minute pitch" id="{9441e1c6-99bb-85ee-3263-3bb51a61db0d}">
+        <p14:section name="3-minute pitch" id="{059eaa20-136e-e065-b9b7-608a53d44689}">
           <p14:sldIdLst>
             <p14:sldId id="256"/>
             <p14:sldId id="257"/>
@@ -145,7 +145,7 @@
             <p14:sldId id="265"/>
           </p14:sldIdLst>
         </p14:section>
-        <p14:section name="The detail" id="{a4386bf0-6f61-0667-b4cd-b5b0318fd033}">
+        <p14:section name="The detail" id="{1bea7bb1-c826-7236-5085-da8a54a53301}">
           <p14:sldIdLst>
             <p14:sldId id="266"/>
             <p14:sldId id="267"/>
@@ -3294,8 +3294,8 @@
           <a:p>
             <a:r>
               <a:rPr lang="en-US" dirty="0"/>
-              <a:t>SAY (0:00-0:15): 'Everyone wants a piece of the kasi economy. Big retailers are moving into townships. On some building sites, groups demand a cut of the work. Because it's worth about R900 billion a year.'
-R900 bn: Standard Bank's Township Informal Economy Report, October 2025 (research by Foshizi, 250+ businesses in 5 provinces). Say 'about R900 billion'. The retailer and building-site lines are lived evidence: no number, so don't add one.
+              <a:t>SAY (0:00-0:15): 'Everyone wants a piece of the kasi economy. Big retailers are moving into townships. Banks and payment apps are fighting for its customers. Because it's worth about R900 billion a year.'
+R900 bn: Standard Bank's Township Informal Economy Report, October 2025 (research by Foshizi, 250+ businesses in 5 provinces). Say 'about R900 billion'. The retailer and bank lines are lived evidence: no number, so don't add one.
 Photos: 'Nomonde Tuck Shop' by HelenOnline (CC BY-SA 4.0) and 'Aliwal North - Dukatole - Housebuilding Projekt' by Heinz-Josef Lücking (CC BY-SA 3.0 DE), Wikimedia Commons, resized, with our captions. Credits are also in REUSE.md.</a:t>
             </a:r>
             <a:endParaRPr lang="en-US" dirty="0"/>
@@ -17019,7 +17019,7 @@
                 <a:ea typeface="Calibri" pitchFamily="34" charset="-122"/>
                 <a:cs typeface="Calibri" pitchFamily="34" charset="-120"/>
               </a:rPr>
-              <a:t>On some building sites, groups demand a cut of the work</a:t>
+              <a:t>Banks and payment apps are fighting for its customers</a:t>
             </a:r>
             <a:endParaRPr lang="en-US" sz="1700" dirty="0"/>
           </a:p>

</xml_diff>

<commit_message>
Deck slide 2: real spaza shop photos (credited), 'hidden in plain sight', 12% of GDP and 1 in 5 jobs; slide 1 'ready for tomorrow'
Co-Authored-By: Claude Opus 5.5 <noreply@anthropic.com>
Claude-Session: https://claude.ai/code/session_01W9vcEkUR51B1hgQFTnjcUh
</commit_message>
<xml_diff>
--- a/docs/submission/05_final_submission/Akayza_Pitch_TeamPR.pptx
+++ b/docs/submission/05_final_submission/Akayza_Pitch_TeamPR.pptx
@@ -1684,8 +1684,9 @@
           <a:p>
             <a:r>
               <a:rPr lang="en-US" dirty="0"/>
-              <a:t>SAY (20 s): 'R900 billion moves through South Africa's township economy every year: shops, builders, food sellers, salons. And nobody can see it. Fewer than 9% of these businesses can get a bank loan. 80% are unregistered. When government put R500 million on the table for spaza shops, only R179.6 million reached them, because 354 applications couldn't be verified. With no record, even help can't reach them.'
-IF ASKED where R900 bn comes from: Standard Bank's Township Informal Economy Report, October 2025, research by Foshizi, 250+ businesses in five provinces. Say 'about R900 billion', never 800.
+              <a:t>SAY (20 s): 'R900 billion moves through South Africa's township economy every year. That's about 12% of our GDP and one in five jobs: shops, builders, food sellers, salons. And it's hidden in plain sight. Fewer than 9% of these businesses can get a bank loan. 80% are unregistered. When government put R500 million on the table for spaza shops, only R179.6 million reached them, because 354 applications couldn't be verified. With no record, even help can't reach them.'
+IF ASKED where R900 bn comes from: Standard Bank's Township Informal Economy Report, October 2025, research by Foshizi, 250+ businesses in five provinces. Say 'about R900 billion', never 800. 12.3% of GDP and ~19.5% of employment: same report.
+MORE EVIDENCE if pushed: DSBD (May 2026): ~82,000 spaza shops registered, 44,696 verified, ~15,000 licensed. NIQ (Mar 2026): traditional trade ~R170.1 bn in sales, growing faster than the big chains.
 The fund figures are specifically about spaza shops, so we name them there. WhatsApp is how they talk; it isn't the problem. The problem is that nothing turns everyday trading into a record.</a:t>
             </a:r>
             <a:endParaRPr lang="en-US" dirty="0"/>
@@ -2834,7 +2835,7 @@
                 <a:ea typeface="Calibri" pitchFamily="34" charset="-122"/>
                 <a:cs typeface="Calibri" pitchFamily="34" charset="-120"/>
               </a:rPr>
-              <a:t>Making South Africa's informal and small businesses visible, and ready for what's next.</a:t>
+              <a:t>Making South Africa's informal and small businesses visible, and ready for tomorrow.</a:t>
             </a:r>
             <a:endParaRPr lang="en-US" sz="1800" dirty="0"/>
           </a:p>
@@ -3557,16 +3558,64 @@
         <p:spPr>
           <a:xfrm>
             <a:off x="7863840" y="0"/>
-            <a:ext cx="4327855" cy="6858000"/>
+            <a:ext cx="4327855" cy="2267712"/>
           </a:xfrm>
           <a:prstGeom prst="rect">
             <a:avLst/>
           </a:prstGeom>
         </p:spPr>
       </p:pic>
-      <p:sp>
-        <p:nvSpPr>
-          <p:cNvPr id="3" name="Text 0"/>
+      <p:pic>
+        <p:nvPicPr>
+          <p:cNvPr id="3" name="Image 1" descr="preencoded.png">    </p:cNvPr>
+          <p:cNvPicPr>
+            <a:picLocks noChangeAspect="1"/>
+          </p:cNvPicPr>
+          <p:nvPr/>
+        </p:nvPicPr>
+        <p:blipFill>
+          <a:blip r:embed="rId2"/>
+          <a:stretch>
+            <a:fillRect/>
+          </a:stretch>
+        </p:blipFill>
+        <p:spPr>
+          <a:xfrm>
+            <a:off x="7863840" y="2304288"/>
+            <a:ext cx="4327855" cy="2267712"/>
+          </a:xfrm>
+          <a:prstGeom prst="rect">
+            <a:avLst/>
+          </a:prstGeom>
+        </p:spPr>
+      </p:pic>
+      <p:pic>
+        <p:nvPicPr>
+          <p:cNvPr id="4" name="Image 2" descr="preencoded.png">    </p:cNvPr>
+          <p:cNvPicPr>
+            <a:picLocks noChangeAspect="1"/>
+          </p:cNvPicPr>
+          <p:nvPr/>
+        </p:nvPicPr>
+        <p:blipFill>
+          <a:blip r:embed="rId3"/>
+          <a:stretch>
+            <a:fillRect/>
+          </a:stretch>
+        </p:blipFill>
+        <p:spPr>
+          <a:xfrm>
+            <a:off x="7863840" y="4608576"/>
+            <a:ext cx="4327855" cy="2267712"/>
+          </a:xfrm>
+          <a:prstGeom prst="rect">
+            <a:avLst/>
+          </a:prstGeom>
+        </p:spPr>
+      </p:pic>
+      <p:sp>
+        <p:nvSpPr>
+          <p:cNvPr id="5" name="Text 0"/>
           <p:cNvSpPr txBox="1"/>
           <p:nvPr/>
         </p:nvSpPr>
@@ -3605,14 +3654,14 @@
       </p:sp>
       <p:sp>
         <p:nvSpPr>
-          <p:cNvPr id="4" name="Text 1"/>
+          <p:cNvPr id="6" name="Text 1"/>
           <p:cNvSpPr txBox="1"/>
           <p:nvPr/>
         </p:nvSpPr>
         <p:spPr>
           <a:xfrm>
             <a:off x="548640" y="731520"/>
-            <a:ext cx="6949440" cy="1188720"/>
+            <a:ext cx="6949440" cy="1143000"/>
           </a:xfrm>
           <a:prstGeom prst="rect">
             <a:avLst/>
@@ -3636,7 +3685,7 @@
                 <a:ea typeface="Georgia" pitchFamily="34" charset="-122"/>
                 <a:cs typeface="Georgia" pitchFamily="34" charset="-120"/>
               </a:rPr>
-              <a:t>R900 billion a year, and nobody can see it</a:t>
+              <a:t>R900 billion a year, hidden in plain sight</a:t>
             </a:r>
             <a:endParaRPr lang="en-US" sz="3200" dirty="0"/>
           </a:p>
@@ -3644,18 +3693,57 @@
       </p:sp>
       <p:sp>
         <p:nvSpPr>
-          <p:cNvPr id="5" name="Shape 2"/>
+          <p:cNvPr id="7" name="Text 2"/>
+          <p:cNvSpPr txBox="1"/>
+          <p:nvPr/>
+        </p:nvSpPr>
+        <p:spPr>
+          <a:xfrm>
+            <a:off x="548640" y="1874520"/>
+            <a:ext cx="6949440" cy="365760"/>
+          </a:xfrm>
+          <a:prstGeom prst="rect">
+            <a:avLst/>
+          </a:prstGeom>
+          <a:noFill/>
+          <a:ln/>
+        </p:spPr>
+        <p:txBody>
+          <a:bodyPr wrap="square" lIns="0" tIns="0" rIns="0" bIns="0" rtlCol="0" anchor="t"/>
+          <a:lstStyle/>
+          <a:p>
+            <a:pPr indent="0" marL="0">
+              <a:buNone/>
+            </a:pPr>
+            <a:r>
+              <a:rPr lang="en-US" sz="1800" dirty="0">
+                <a:solidFill>
+                  <a:srgbClr val="FBBF24"/>
+                </a:solidFill>
+                <a:latin typeface="Calibri" pitchFamily="34" charset="0"/>
+                <a:ea typeface="Calibri" pitchFamily="34" charset="-122"/>
+                <a:cs typeface="Calibri" pitchFamily="34" charset="-120"/>
+              </a:rPr>
+              <a:t>About 12% of South Africa's GDP, and 1 in 5 jobs.</a:t>
+            </a:r>
+            <a:endParaRPr lang="en-US" sz="1800" dirty="0"/>
+          </a:p>
+        </p:txBody>
+      </p:sp>
+      <p:sp>
+        <p:nvSpPr>
+          <p:cNvPr id="8" name="Shape 3"/>
           <p:cNvSpPr/>
           <p:nvPr/>
         </p:nvSpPr>
         <p:spPr>
           <a:xfrm>
-            <a:off x="548640" y="2103120"/>
-            <a:ext cx="2194560" cy="1600200"/>
+            <a:off x="548640" y="2423160"/>
+            <a:ext cx="2194560" cy="1417320"/>
           </a:xfrm>
           <a:prstGeom prst="roundRect">
             <a:avLst>
-              <a:gd name="adj" fmla="val 6857"/>
+              <a:gd name="adj" fmla="val 7742"/>
             </a:avLst>
           </a:prstGeom>
           <a:solidFill>
@@ -3671,13 +3759,13 @@
       </p:sp>
       <p:sp>
         <p:nvSpPr>
-          <p:cNvPr id="6" name="Text 3"/>
-          <p:cNvSpPr txBox="1"/>
-          <p:nvPr/>
-        </p:nvSpPr>
-        <p:spPr>
-          <a:xfrm>
-            <a:off x="777240" y="2240280"/>
+          <p:cNvPr id="9" name="Text 4"/>
+          <p:cNvSpPr txBox="1"/>
+          <p:nvPr/>
+        </p:nvSpPr>
+        <p:spPr>
+          <a:xfrm>
+            <a:off x="777240" y="2514600"/>
             <a:ext cx="1828800" cy="731520"/>
           </a:xfrm>
           <a:prstGeom prst="rect">
@@ -3710,13 +3798,13 @@
       </p:sp>
       <p:sp>
         <p:nvSpPr>
-          <p:cNvPr id="7" name="Text 4"/>
-          <p:cNvSpPr txBox="1"/>
-          <p:nvPr/>
-        </p:nvSpPr>
-        <p:spPr>
-          <a:xfrm>
-            <a:off x="777240" y="3017520"/>
+          <p:cNvPr id="10" name="Text 5"/>
+          <p:cNvSpPr txBox="1"/>
+          <p:nvPr/>
+        </p:nvSpPr>
+        <p:spPr>
+          <a:xfrm>
+            <a:off x="777240" y="3246120"/>
             <a:ext cx="1828800" cy="594360"/>
           </a:xfrm>
           <a:prstGeom prst="rect">
@@ -3749,18 +3837,18 @@
       </p:sp>
       <p:sp>
         <p:nvSpPr>
-          <p:cNvPr id="8" name="Shape 5"/>
+          <p:cNvPr id="11" name="Shape 6"/>
           <p:cNvSpPr/>
           <p:nvPr/>
         </p:nvSpPr>
         <p:spPr>
           <a:xfrm>
-            <a:off x="2926080" y="2103120"/>
-            <a:ext cx="2194560" cy="1600200"/>
+            <a:off x="2926080" y="2423160"/>
+            <a:ext cx="2194560" cy="1417320"/>
           </a:xfrm>
           <a:prstGeom prst="roundRect">
             <a:avLst>
-              <a:gd name="adj" fmla="val 6857"/>
+              <a:gd name="adj" fmla="val 7742"/>
             </a:avLst>
           </a:prstGeom>
           <a:solidFill>
@@ -3776,13 +3864,13 @@
       </p:sp>
       <p:sp>
         <p:nvSpPr>
-          <p:cNvPr id="9" name="Text 6"/>
-          <p:cNvSpPr txBox="1"/>
-          <p:nvPr/>
-        </p:nvSpPr>
-        <p:spPr>
-          <a:xfrm>
-            <a:off x="3154680" y="2240280"/>
+          <p:cNvPr id="12" name="Text 7"/>
+          <p:cNvSpPr txBox="1"/>
+          <p:nvPr/>
+        </p:nvSpPr>
+        <p:spPr>
+          <a:xfrm>
+            <a:off x="3154680" y="2514600"/>
             <a:ext cx="1828800" cy="731520"/>
           </a:xfrm>
           <a:prstGeom prst="rect">
@@ -3815,13 +3903,13 @@
       </p:sp>
       <p:sp>
         <p:nvSpPr>
-          <p:cNvPr id="10" name="Text 7"/>
-          <p:cNvSpPr txBox="1"/>
-          <p:nvPr/>
-        </p:nvSpPr>
-        <p:spPr>
-          <a:xfrm>
-            <a:off x="3154680" y="3017520"/>
+          <p:cNvPr id="13" name="Text 8"/>
+          <p:cNvSpPr txBox="1"/>
+          <p:nvPr/>
+        </p:nvSpPr>
+        <p:spPr>
+          <a:xfrm>
+            <a:off x="3154680" y="3246120"/>
             <a:ext cx="1828800" cy="594360"/>
           </a:xfrm>
           <a:prstGeom prst="rect">
@@ -3854,18 +3942,18 @@
       </p:sp>
       <p:sp>
         <p:nvSpPr>
-          <p:cNvPr id="11" name="Shape 8"/>
+          <p:cNvPr id="14" name="Shape 9"/>
           <p:cNvSpPr/>
           <p:nvPr/>
         </p:nvSpPr>
         <p:spPr>
           <a:xfrm>
-            <a:off x="5303520" y="2103120"/>
-            <a:ext cx="2194560" cy="1600200"/>
+            <a:off x="5303520" y="2423160"/>
+            <a:ext cx="2194560" cy="1417320"/>
           </a:xfrm>
           <a:prstGeom prst="roundRect">
             <a:avLst>
-              <a:gd name="adj" fmla="val 6857"/>
+              <a:gd name="adj" fmla="val 7742"/>
             </a:avLst>
           </a:prstGeom>
           <a:solidFill>
@@ -3881,13 +3969,13 @@
       </p:sp>
       <p:sp>
         <p:nvSpPr>
-          <p:cNvPr id="12" name="Text 9"/>
-          <p:cNvSpPr txBox="1"/>
-          <p:nvPr/>
-        </p:nvSpPr>
-        <p:spPr>
-          <a:xfrm>
-            <a:off x="5532120" y="2240280"/>
+          <p:cNvPr id="15" name="Text 10"/>
+          <p:cNvSpPr txBox="1"/>
+          <p:nvPr/>
+        </p:nvSpPr>
+        <p:spPr>
+          <a:xfrm>
+            <a:off x="5532120" y="2514600"/>
             <a:ext cx="1828800" cy="731520"/>
           </a:xfrm>
           <a:prstGeom prst="rect">
@@ -3920,13 +4008,13 @@
       </p:sp>
       <p:sp>
         <p:nvSpPr>
-          <p:cNvPr id="13" name="Text 10"/>
-          <p:cNvSpPr txBox="1"/>
-          <p:nvPr/>
-        </p:nvSpPr>
-        <p:spPr>
-          <a:xfrm>
-            <a:off x="5532120" y="3017520"/>
+          <p:cNvPr id="16" name="Text 11"/>
+          <p:cNvSpPr txBox="1"/>
+          <p:nvPr/>
+        </p:nvSpPr>
+        <p:spPr>
+          <a:xfrm>
+            <a:off x="5532120" y="3246120"/>
             <a:ext cx="1828800" cy="594360"/>
           </a:xfrm>
           <a:prstGeom prst="rect">
@@ -3959,18 +4047,18 @@
       </p:sp>
       <p:sp>
         <p:nvSpPr>
-          <p:cNvPr id="14" name="Shape 11"/>
+          <p:cNvPr id="17" name="Shape 12"/>
           <p:cNvSpPr/>
           <p:nvPr/>
         </p:nvSpPr>
         <p:spPr>
           <a:xfrm>
-            <a:off x="548640" y="3931920"/>
-            <a:ext cx="6949440" cy="2194560"/>
+            <a:off x="548640" y="4023360"/>
+            <a:ext cx="6949440" cy="2148840"/>
           </a:xfrm>
           <a:prstGeom prst="roundRect">
             <a:avLst>
-              <a:gd name="adj" fmla="val 5000"/>
+              <a:gd name="adj" fmla="val 5106"/>
             </a:avLst>
           </a:prstGeom>
           <a:solidFill>
@@ -3986,30 +4074,30 @@
       </p:sp>
       <p:graphicFrame>
         <p:nvGraphicFramePr>
-          <p:cNvPr id="15" name="Chart 0" descr=""/>
+          <p:cNvPr id="18" name="Chart 0" descr=""/>
           <p:cNvGraphicFramePr/>
           <p:nvPr/>
         </p:nvGraphicFramePr>
         <p:xfrm>
-          <a:off x="685800" y="4023360"/>
+          <a:off x="685800" y="4096512"/>
           <a:ext cx="4206240" cy="2011680"/>
         </p:xfrm>
         <a:graphic xmlns:a="http://schemas.openxmlformats.org/drawingml/2006/main">
           <a:graphicData uri="http://schemas.openxmlformats.org/drawingml/2006/chart">
-            <c:chart xmlns:c="http://schemas.openxmlformats.org/drawingml/2006/chart" r:id="rId2"/>
+            <c:chart xmlns:c="http://schemas.openxmlformats.org/drawingml/2006/chart" r:id="rId4"/>
           </a:graphicData>
         </a:graphic>
       </p:graphicFrame>
       <p:sp>
         <p:nvSpPr>
-          <p:cNvPr id="16" name="Text 12"/>
-          <p:cNvSpPr txBox="1"/>
-          <p:nvPr/>
-        </p:nvSpPr>
-        <p:spPr>
-          <a:xfrm>
-            <a:off x="4983480" y="4251960"/>
-            <a:ext cx="2331720" cy="1737360"/>
+          <p:cNvPr id="19" name="Text 13"/>
+          <p:cNvSpPr txBox="1"/>
+          <p:nvPr/>
+        </p:nvSpPr>
+        <p:spPr>
+          <a:xfrm>
+            <a:off x="4983480" y="4206240"/>
+            <a:ext cx="2331720" cy="1828800"/>
           </a:xfrm>
           <a:prstGeom prst="rect">
             <a:avLst/>
@@ -4041,14 +4129,14 @@
       </p:sp>
       <p:pic>
         <p:nvPicPr>
-          <p:cNvPr id="17" name="Image 1" descr="preencoded.png">    </p:cNvPr>
+          <p:cNvPr id="20" name="Image 3" descr="preencoded.png">    </p:cNvPr>
           <p:cNvPicPr>
             <a:picLocks noChangeAspect="1"/>
           </p:cNvPicPr>
           <p:nvPr/>
         </p:nvPicPr>
         <p:blipFill>
-          <a:blip r:embed="rId3"/>
+          <a:blip r:embed="rId5"/>
           <a:stretch>
             <a:fillRect/>
           </a:stretch>
@@ -4065,7 +4153,7 @@
       </p:pic>
       <p:sp>
         <p:nvSpPr>
-          <p:cNvPr id="18" name="Text 13"/>
+          <p:cNvPr id="21" name="Text 14"/>
           <p:cNvSpPr txBox="1"/>
           <p:nvPr/>
         </p:nvSpPr>
@@ -4104,7 +4192,7 @@
       </p:sp>
       <p:sp>
         <p:nvSpPr>
-          <p:cNvPr id="19" name="Text 14"/>
+          <p:cNvPr id="22" name="Text 15"/>
           <p:cNvSpPr txBox="1"/>
           <p:nvPr/>
         </p:nvSpPr>
@@ -4135,7 +4223,7 @@
                 <a:ea typeface="Calibri" pitchFamily="34" charset="-122"/>
                 <a:cs typeface="Calibri" pitchFamily="34" charset="-120"/>
               </a:rPr>
-              <a:t>Standard Bank Township Informal Economy Report, Oct 2025; DSBD, Spaza Shop Support Fund update, May 2026.</a:t>
+              <a:t>Standard Bank, Oct 2025; DSBD, May 2026. Photos: Business Explainer; SABC News.</a:t>
             </a:r>
             <a:endParaRPr lang="en-US" sz="950" dirty="0"/>
           </a:p>

</xml_diff>

<commit_message>
Deck slides 3-4: users vs customers vs partners, honest limit on proof, Thandi's week starts with her suppliers
Co-Authored-By: Claude Opus 5.5 <noreply@anthropic.com>
Claude-Session: https://claude.ai/code/session_01W9vcEkUR51B1hgQFTnjcUh
</commit_message>
<xml_diff>
--- a/docs/submission/05_final_submission/Akayza_Pitch_TeamPR.pptx
+++ b/docs/submission/05_final_submission/Akayza_Pitch_TeamPR.pptx
@@ -1775,8 +1775,9 @@
           <a:p>
             <a:r>
               <a:rPr lang="en-US" dirty="0"/>
-              <a:t>SAY (25 s): 'That's where Akayza comes in. One free app that runs the business the way it already works, and turns every sale, order and payment into a record the owner holds. Today, less stress. This week, they buy better from their own suppliers and pay safely. Tomorrow, a trading history they own: the first step to credit and funding. Businesses never pay. Suppliers pay us, because we bring them more orders.'
-Honest wording if pushed: payments made in the app are confirmed by the payment provider; the rest is the owner's own record. Never call tool records 'proof'.</a:t>
+              <a:t>SAY (25 s): 'That's where Akayza comes in. One free app that makes the business visible, and ready for tomorrow. It works the way they already operate, cash or digital. Every digital stock order becomes a record the owner holds, and over time a strong trading history. Today, the business tools take the stress away. This week, they buy better from their own suppliers and pay safely. Tomorrow, that history is their first step to finance. Businesses never pay. Suppliers are our customers: they pay a monthly fee because we bring them more orders, paid up front. And next, banks and lenders, as partners, only with the owner's consent.'
+HONEST LIMIT (say it before a judge does): 'We only call digital payments proof, because the payment provider confirms the money moved. Cash and what an owner writes in the tools is their own record. We never add them together.'
+We don't lend or offer credit ourselves; banks and lenders are future partners.</a:t>
             </a:r>
             <a:endParaRPr lang="en-US" dirty="0"/>
           </a:p>
@@ -1864,8 +1865,8 @@
           <a:p>
             <a:r>
               <a:rPr lang="en-US" dirty="0"/>
-              <a:t>SAY (20 s), tell it as a story: 'Meet Thandi. Monday she restocks from her usual supplier in two minutes. Wednesday a customer pays back his credit. Friday she pays her supplier in the app: no cash on the road, the payment is confirmed and the invoice arrives. And at month end, for the first time, she can see her business, and it's hers.'
-Thandi and Sipho are illustrations, not real customers. If asked: 'they're the owners we built for; the pilot puts real names to them.'</a:t>
+              <a:t>SAY (20 s), tell it as a story: 'Meet Thandi. Her customers pay her in cash, and there's no proof that money moved. But with her suppliers there can be, so that's where we start. Monday she restocks from her usual supplier in two minutes. Wednesday a customer pays back his credit, and she records it in her credit book. Friday she pays her supplier in the app: no cash on the road, the payment is confirmed and the invoice arrives. And at month end she sees her business: who owes her, what she orders most, and the suppliers that fit how she buys.' Then: 'Any informal business has the same week, like Sipho the builder.'
+We recommend suppliers, never products: the month-end view is her own numbers. Thandi and Sipho are illustrations, not real customers.</a:t>
             </a:r>
             <a:endParaRPr lang="en-US" dirty="0"/>
           </a:p>
@@ -4309,7 +4310,7 @@
         <p:spPr>
           <a:xfrm>
             <a:off x="548640" y="731520"/>
-            <a:ext cx="11094415" cy="868680"/>
+            <a:ext cx="11064240" cy="1005840"/>
           </a:xfrm>
           <a:prstGeom prst="rect">
             <a:avLst/>
@@ -4325,7 +4326,7 @@
               <a:buNone/>
             </a:pPr>
             <a:r>
-              <a:rPr lang="en-US" sz="3200" b="1" dirty="0">
+              <a:rPr lang="en-US" sz="3000" b="1" dirty="0">
                 <a:solidFill>
                   <a:srgbClr val="F8FAFC"/>
                 </a:solidFill>
@@ -4333,9 +4334,9 @@
                 <a:ea typeface="Georgia" pitchFamily="34" charset="-122"/>
                 <a:cs typeface="Georgia" pitchFamily="34" charset="-120"/>
               </a:rPr>
-              <a:t>One free app that makes the business visible</a:t>
-            </a:r>
-            <a:endParaRPr lang="en-US" sz="3200" dirty="0"/>
+              <a:t>One free app that makes the business visible, and ready for tomorrow</a:t>
+            </a:r>
+            <a:endParaRPr lang="en-US" sz="3000" dirty="0"/>
           </a:p>
         </p:txBody>
       </p:sp>
@@ -4347,8 +4348,8 @@
         </p:nvSpPr>
         <p:spPr>
           <a:xfrm>
-            <a:off x="548640" y="1600200"/>
-            <a:ext cx="11064240" cy="685800"/>
+            <a:off x="548640" y="1783080"/>
+            <a:ext cx="11064240" cy="731520"/>
           </a:xfrm>
           <a:prstGeom prst="rect">
             <a:avLst/>
@@ -4364,7 +4365,7 @@
               <a:buNone/>
             </a:pPr>
             <a:r>
-              <a:rPr lang="en-US" sz="1700" dirty="0">
+              <a:rPr lang="en-US" sz="1550" dirty="0">
                 <a:solidFill>
                   <a:srgbClr val="A3B3C9"/>
                 </a:solidFill>
@@ -4372,9 +4373,9 @@
                 <a:ea typeface="Calibri" pitchFamily="34" charset="-122"/>
                 <a:cs typeface="Calibri" pitchFamily="34" charset="-120"/>
               </a:rPr>
-              <a:t>It works the way they already do (cash, credit on trust, the same suppliers), and turns every sale, order and payment into a record the owner holds.</a:t>
-            </a:r>
-            <a:endParaRPr lang="en-US" sz="1700" dirty="0"/>
+              <a:t>It works the way they already operate, with cash and digital payments. Every digital stock order becomes a record the owner holds, and over time a strong trading history, alongside the business tools they use every day.</a:t>
+            </a:r>
+            <a:endParaRPr lang="en-US" sz="1550" dirty="0"/>
           </a:p>
         </p:txBody>
       </p:sp>
@@ -4386,12 +4387,12 @@
         </p:nvSpPr>
         <p:spPr>
           <a:xfrm>
-            <a:off x="548640" y="2468880"/>
-            <a:ext cx="3474720" cy="2788920"/>
+            <a:off x="548640" y="2606040"/>
+            <a:ext cx="3474720" cy="2103120"/>
           </a:xfrm>
           <a:prstGeom prst="roundRect">
             <a:avLst>
-              <a:gd name="adj" fmla="val 3934"/>
+              <a:gd name="adj" fmla="val 5217"/>
             </a:avLst>
           </a:prstGeom>
           <a:solidFill>
@@ -4413,7 +4414,7 @@
         </p:nvSpPr>
         <p:spPr>
           <a:xfrm>
-            <a:off x="868680" y="2697480"/>
+            <a:off x="822960" y="2761488"/>
             <a:ext cx="2286000" cy="320040"/>
           </a:xfrm>
           <a:prstGeom prst="rect">
@@ -4430,7 +4431,7 @@
               <a:buNone/>
             </a:pPr>
             <a:r>
-              <a:rPr lang="en-US" sz="1300" b="1" spc="300" kern="0" dirty="0">
+              <a:rPr lang="en-US" sz="1250" b="1" spc="300" kern="0" dirty="0">
                 <a:solidFill>
                   <a:srgbClr val="10B981"/>
                 </a:solidFill>
@@ -4440,7 +4441,7 @@
               </a:rPr>
               <a:t>TODAY</a:t>
             </a:r>
-            <a:endParaRPr lang="en-US" sz="1300" dirty="0"/>
+            <a:endParaRPr lang="en-US" sz="1250" dirty="0"/>
           </a:p>
         </p:txBody>
       </p:sp>
@@ -4452,8 +4453,8 @@
         </p:nvSpPr>
         <p:spPr>
           <a:xfrm>
-            <a:off x="3063240" y="2651760"/>
-            <a:ext cx="658368" cy="658368"/>
+            <a:off x="3291840" y="2715768"/>
+            <a:ext cx="475488" cy="475488"/>
           </a:xfrm>
           <a:prstGeom prst="ellipse">
             <a:avLst/>
@@ -4485,8 +4486,8 @@
         </p:blipFill>
         <p:spPr>
           <a:xfrm>
-            <a:off x="3221248" y="2809768"/>
-            <a:ext cx="342351" cy="342351"/>
+            <a:off x="3405957" y="2829885"/>
+            <a:ext cx="247254" cy="247254"/>
           </a:xfrm>
           <a:prstGeom prst="rect">
             <a:avLst/>
@@ -4501,8 +4502,8 @@
         </p:nvSpPr>
         <p:spPr>
           <a:xfrm>
-            <a:off x="868680" y="3383280"/>
-            <a:ext cx="3017520" cy="457200"/>
+            <a:off x="822960" y="3200400"/>
+            <a:ext cx="3017520" cy="411480"/>
           </a:xfrm>
           <a:prstGeom prst="rect">
             <a:avLst/>
@@ -4518,7 +4519,7 @@
               <a:buNone/>
             </a:pPr>
             <a:r>
-              <a:rPr lang="en-US" sz="1900" b="1" dirty="0">
+              <a:rPr lang="en-US" sz="1800" b="1" dirty="0">
                 <a:solidFill>
                   <a:srgbClr val="F8FAFC"/>
                 </a:solidFill>
@@ -4528,7 +4529,7 @@
               </a:rPr>
               <a:t>Less stress</a:t>
             </a:r>
-            <a:endParaRPr lang="en-US" sz="1900" dirty="0"/>
+            <a:endParaRPr lang="en-US" sz="1800" dirty="0"/>
           </a:p>
         </p:txBody>
       </p:sp>
@@ -4540,8 +4541,8 @@
         </p:nvSpPr>
         <p:spPr>
           <a:xfrm>
-            <a:off x="868680" y="3931920"/>
-            <a:ext cx="2880360" cy="1234440"/>
+            <a:off x="822960" y="3657600"/>
+            <a:ext cx="2971800" cy="1005840"/>
           </a:xfrm>
           <a:prstGeom prst="rect">
             <a:avLst/>
@@ -4557,7 +4558,7 @@
               <a:buNone/>
             </a:pPr>
             <a:r>
-              <a:rPr lang="en-US" sz="1400" dirty="0">
+              <a:rPr lang="en-US" sz="1300" dirty="0">
                 <a:solidFill>
                   <a:srgbClr val="A3B3C9"/>
                 </a:solidFill>
@@ -4565,9 +4566,9 @@
                 <a:ea typeface="Calibri" pitchFamily="34" charset="-122"/>
                 <a:cs typeface="Calibri" pitchFamily="34" charset="-120"/>
               </a:rPr>
-              <a:t>A credit book, an order book and jobs in stages: who owes you, what sold, what's due.</a:t>
-            </a:r>
-            <a:endParaRPr lang="en-US" sz="1400" dirty="0"/>
+              <a:t>Business tools in one place: a credit book, an order book, jobs in stages and My record.</a:t>
+            </a:r>
+            <a:endParaRPr lang="en-US" sz="1300" dirty="0"/>
           </a:p>
         </p:txBody>
       </p:sp>
@@ -4579,12 +4580,12 @@
         </p:nvSpPr>
         <p:spPr>
           <a:xfrm>
-            <a:off x="4297680" y="2468880"/>
-            <a:ext cx="3474720" cy="2788920"/>
+            <a:off x="4297680" y="2606040"/>
+            <a:ext cx="3474720" cy="2103120"/>
           </a:xfrm>
           <a:prstGeom prst="roundRect">
             <a:avLst>
-              <a:gd name="adj" fmla="val 3934"/>
+              <a:gd name="adj" fmla="val 5217"/>
             </a:avLst>
           </a:prstGeom>
           <a:solidFill>
@@ -4606,7 +4607,7 @@
         </p:nvSpPr>
         <p:spPr>
           <a:xfrm>
-            <a:off x="4617720" y="2697480"/>
+            <a:off x="4572000" y="2761488"/>
             <a:ext cx="2286000" cy="320040"/>
           </a:xfrm>
           <a:prstGeom prst="rect">
@@ -4623,7 +4624,7 @@
               <a:buNone/>
             </a:pPr>
             <a:r>
-              <a:rPr lang="en-US" sz="1300" b="1" spc="300" kern="0" dirty="0">
+              <a:rPr lang="en-US" sz="1250" b="1" spc="300" kern="0" dirty="0">
                 <a:solidFill>
                   <a:srgbClr val="FBBF24"/>
                 </a:solidFill>
@@ -4633,7 +4634,7 @@
               </a:rPr>
               <a:t>THIS WEEK</a:t>
             </a:r>
-            <a:endParaRPr lang="en-US" sz="1300" dirty="0"/>
+            <a:endParaRPr lang="en-US" sz="1250" dirty="0"/>
           </a:p>
         </p:txBody>
       </p:sp>
@@ -4645,8 +4646,8 @@
         </p:nvSpPr>
         <p:spPr>
           <a:xfrm>
-            <a:off x="6812280" y="2651760"/>
-            <a:ext cx="658368" cy="658368"/>
+            <a:off x="7040880" y="2715768"/>
+            <a:ext cx="475488" cy="475488"/>
           </a:xfrm>
           <a:prstGeom prst="ellipse">
             <a:avLst/>
@@ -4678,8 +4679,8 @@
         </p:blipFill>
         <p:spPr>
           <a:xfrm>
-            <a:off x="6970288" y="2809768"/>
-            <a:ext cx="342351" cy="342351"/>
+            <a:off x="7154997" y="2829885"/>
+            <a:ext cx="247254" cy="247254"/>
           </a:xfrm>
           <a:prstGeom prst="rect">
             <a:avLst/>
@@ -4694,8 +4695,8 @@
         </p:nvSpPr>
         <p:spPr>
           <a:xfrm>
-            <a:off x="4617720" y="3383280"/>
-            <a:ext cx="3017520" cy="457200"/>
+            <a:off x="4572000" y="3200400"/>
+            <a:ext cx="3017520" cy="411480"/>
           </a:xfrm>
           <a:prstGeom prst="rect">
             <a:avLst/>
@@ -4711,7 +4712,7 @@
               <a:buNone/>
             </a:pPr>
             <a:r>
-              <a:rPr lang="en-US" sz="1900" b="1" dirty="0">
+              <a:rPr lang="en-US" sz="1800" b="1" dirty="0">
                 <a:solidFill>
                   <a:srgbClr val="F8FAFC"/>
                 </a:solidFill>
@@ -4721,7 +4722,7 @@
               </a:rPr>
               <a:t>Buy better, pay safely</a:t>
             </a:r>
-            <a:endParaRPr lang="en-US" sz="1900" dirty="0"/>
+            <a:endParaRPr lang="en-US" sz="1800" dirty="0"/>
           </a:p>
         </p:txBody>
       </p:sp>
@@ -4733,8 +4734,8 @@
         </p:nvSpPr>
         <p:spPr>
           <a:xfrm>
-            <a:off x="4617720" y="3931920"/>
-            <a:ext cx="2880360" cy="1234440"/>
+            <a:off x="4572000" y="3657600"/>
+            <a:ext cx="2971800" cy="1005840"/>
           </a:xfrm>
           <a:prstGeom prst="rect">
             <a:avLst/>
@@ -4750,7 +4751,7 @@
               <a:buNone/>
             </a:pPr>
             <a:r>
-              <a:rPr lang="en-US" sz="1400" dirty="0">
+              <a:rPr lang="en-US" sz="1300" dirty="0">
                 <a:solidFill>
                   <a:srgbClr val="A3B3C9"/>
                 </a:solidFill>
@@ -4760,7 +4761,7 @@
               </a:rPr>
               <a:t>Order from your own suppliers, matched to what you really buy. Pay digitally or cash, get a proper invoice.</a:t>
             </a:r>
-            <a:endParaRPr lang="en-US" sz="1400" dirty="0"/>
+            <a:endParaRPr lang="en-US" sz="1300" dirty="0"/>
           </a:p>
         </p:txBody>
       </p:sp>
@@ -4772,12 +4773,12 @@
         </p:nvSpPr>
         <p:spPr>
           <a:xfrm>
-            <a:off x="8046720" y="2468880"/>
-            <a:ext cx="3474720" cy="2788920"/>
+            <a:off x="8046720" y="2606040"/>
+            <a:ext cx="3474720" cy="2103120"/>
           </a:xfrm>
           <a:prstGeom prst="roundRect">
             <a:avLst>
-              <a:gd name="adj" fmla="val 3934"/>
+              <a:gd name="adj" fmla="val 5217"/>
             </a:avLst>
           </a:prstGeom>
           <a:solidFill>
@@ -4799,7 +4800,7 @@
         </p:nvSpPr>
         <p:spPr>
           <a:xfrm>
-            <a:off x="8366760" y="2697480"/>
+            <a:off x="8321040" y="2761488"/>
             <a:ext cx="2286000" cy="320040"/>
           </a:xfrm>
           <a:prstGeom prst="rect">
@@ -4816,7 +4817,7 @@
               <a:buNone/>
             </a:pPr>
             <a:r>
-              <a:rPr lang="en-US" sz="1300" b="1" spc="300" kern="0" dirty="0">
+              <a:rPr lang="en-US" sz="1250" b="1" spc="300" kern="0" dirty="0">
                 <a:solidFill>
                   <a:srgbClr val="34D399"/>
                 </a:solidFill>
@@ -4826,7 +4827,7 @@
               </a:rPr>
               <a:t>TOMORROW</a:t>
             </a:r>
-            <a:endParaRPr lang="en-US" sz="1300" dirty="0"/>
+            <a:endParaRPr lang="en-US" sz="1250" dirty="0"/>
           </a:p>
         </p:txBody>
       </p:sp>
@@ -4838,8 +4839,8 @@
         </p:nvSpPr>
         <p:spPr>
           <a:xfrm>
-            <a:off x="10561320" y="2651760"/>
-            <a:ext cx="658368" cy="658368"/>
+            <a:off x="10789920" y="2715768"/>
+            <a:ext cx="475488" cy="475488"/>
           </a:xfrm>
           <a:prstGeom prst="ellipse">
             <a:avLst/>
@@ -4871,8 +4872,8 @@
         </p:blipFill>
         <p:spPr>
           <a:xfrm>
-            <a:off x="10719328" y="2809768"/>
-            <a:ext cx="342351" cy="342351"/>
+            <a:off x="10904037" y="2829885"/>
+            <a:ext cx="247254" cy="247254"/>
           </a:xfrm>
           <a:prstGeom prst="rect">
             <a:avLst/>
@@ -4887,8 +4888,8 @@
         </p:nvSpPr>
         <p:spPr>
           <a:xfrm>
-            <a:off x="8366760" y="3383280"/>
-            <a:ext cx="3017520" cy="457200"/>
+            <a:off x="8321040" y="3200400"/>
+            <a:ext cx="3017520" cy="411480"/>
           </a:xfrm>
           <a:prstGeom prst="rect">
             <a:avLst/>
@@ -4904,7 +4905,7 @@
               <a:buNone/>
             </a:pPr>
             <a:r>
-              <a:rPr lang="en-US" sz="1900" b="1" dirty="0">
+              <a:rPr lang="en-US" sz="1800" b="1" dirty="0">
                 <a:solidFill>
                   <a:srgbClr val="F8FAFC"/>
                 </a:solidFill>
@@ -4914,7 +4915,7 @@
               </a:rPr>
               <a:t>Ready to grow</a:t>
             </a:r>
-            <a:endParaRPr lang="en-US" sz="1900" dirty="0"/>
+            <a:endParaRPr lang="en-US" sz="1800" dirty="0"/>
           </a:p>
         </p:txBody>
       </p:sp>
@@ -4926,8 +4927,8 @@
         </p:nvSpPr>
         <p:spPr>
           <a:xfrm>
-            <a:off x="8366760" y="3931920"/>
-            <a:ext cx="2880360" cy="1234440"/>
+            <a:off x="8321040" y="3657600"/>
+            <a:ext cx="2971800" cy="1005840"/>
           </a:xfrm>
           <a:prstGeom prst="rect">
             <a:avLst/>
@@ -4943,7 +4944,7 @@
               <a:buNone/>
             </a:pPr>
             <a:r>
-              <a:rPr lang="en-US" sz="1400" dirty="0">
+              <a:rPr lang="en-US" sz="1300" dirty="0">
                 <a:solidFill>
                   <a:srgbClr val="A3B3C9"/>
                 </a:solidFill>
@@ -4951,9 +4952,9 @@
                 <a:ea typeface="Calibri" pitchFamily="34" charset="-122"/>
                 <a:cs typeface="Calibri" pitchFamily="34" charset="-120"/>
               </a:rPr>
-              <a:t>A sealed trading history you own and choose to share: the first step to credit, funds and registration.</a:t>
-            </a:r>
-            <a:endParaRPr lang="en-US" sz="1400" dirty="0"/>
+              <a:t>A sealed trading history you own and choose to share: the first step to finance and registration.</a:t>
+            </a:r>
+            <a:endParaRPr lang="en-US" sz="1300" dirty="0"/>
           </a:p>
         </p:txBody>
       </p:sp>
@@ -4965,12 +4966,12 @@
         </p:nvSpPr>
         <p:spPr>
           <a:xfrm>
-            <a:off x="548640" y="5440680"/>
-            <a:ext cx="11064240" cy="731520"/>
+            <a:off x="548640" y="4846320"/>
+            <a:ext cx="2743200" cy="1371600"/>
           </a:xfrm>
           <a:prstGeom prst="roundRect">
             <a:avLst>
-              <a:gd name="adj" fmla="val 15000"/>
+              <a:gd name="adj" fmla="val 8000"/>
             </a:avLst>
           </a:prstGeom>
           <a:solidFill>
@@ -4992,144 +4993,246 @@
         </p:nvSpPr>
         <p:spPr>
           <a:xfrm>
-            <a:off x="777240" y="5577840"/>
-            <a:ext cx="3566160" cy="457200"/>
-          </a:xfrm>
-          <a:prstGeom prst="rect">
-            <a:avLst/>
-          </a:prstGeom>
-          <a:noFill/>
-          <a:ln/>
-        </p:spPr>
-        <p:txBody>
-          <a:bodyPr wrap="square" lIns="0" tIns="0" rIns="0" bIns="0" rtlCol="0" anchor="ctr"/>
+            <a:off x="749808" y="4937760"/>
+            <a:ext cx="2377440" cy="256032"/>
+          </a:xfrm>
+          <a:prstGeom prst="rect">
+            <a:avLst/>
+          </a:prstGeom>
+          <a:noFill/>
+          <a:ln/>
+        </p:spPr>
+        <p:txBody>
+          <a:bodyPr wrap="square" lIns="0" tIns="0" rIns="0" bIns="0" rtlCol="0" anchor="t"/>
           <a:lstStyle/>
           <a:p>
             <a:pPr indent="0" marL="0">
               <a:buNone/>
             </a:pPr>
             <a:r>
-              <a:rPr lang="en-US" sz="1350" b="1" dirty="0">
-                <a:solidFill>
-                  <a:srgbClr val="10B981"/>
+              <a:rPr lang="en-US" sz="1050" b="1" spc="200" kern="0" dirty="0">
+                <a:solidFill>
+                  <a:srgbClr val="A3B3C9"/>
                 </a:solidFill>
                 <a:latin typeface="Calibri" pitchFamily="34" charset="0"/>
                 <a:ea typeface="Calibri" pitchFamily="34" charset="-122"/>
                 <a:cs typeface="Calibri" pitchFamily="34" charset="-120"/>
               </a:rPr>
-              <a:t>Businesses  </a:t>
-            </a:r>
+              <a:t>USERS</a:t>
+            </a:r>
+            <a:endParaRPr lang="en-US" sz="1050" dirty="0"/>
+          </a:p>
+        </p:txBody>
+      </p:sp>
+      <p:sp>
+        <p:nvSpPr>
+          <p:cNvPr id="25" name="Text 20"/>
+          <p:cNvSpPr txBox="1"/>
+          <p:nvPr/>
+        </p:nvSpPr>
+        <p:spPr>
+          <a:xfrm>
+            <a:off x="749808" y="5175504"/>
+            <a:ext cx="2377440" cy="320040"/>
+          </a:xfrm>
+          <a:prstGeom prst="rect">
+            <a:avLst/>
+          </a:prstGeom>
+          <a:noFill/>
+          <a:ln/>
+        </p:spPr>
+        <p:txBody>
+          <a:bodyPr wrap="square" lIns="0" tIns="0" rIns="0" bIns="0" rtlCol="0" anchor="t"/>
+          <a:lstStyle/>
+          <a:p>
             <a:pPr indent="0" marL="0">
               <a:buNone/>
             </a:pPr>
             <a:r>
-              <a:rPr lang="en-US" sz="1350" dirty="0">
-                <a:solidFill>
-                  <a:srgbClr val="F8FAFC"/>
+              <a:rPr lang="en-US" sz="1500" b="1" dirty="0">
+                <a:solidFill>
+                  <a:srgbClr val="10B981"/>
                 </a:solidFill>
                 <a:latin typeface="Calibri" pitchFamily="34" charset="0"/>
                 <a:ea typeface="Calibri" pitchFamily="34" charset="-122"/>
                 <a:cs typeface="Calibri" pitchFamily="34" charset="-120"/>
               </a:rPr>
-              <a:t>use it free, always</a:t>
-            </a:r>
-            <a:endParaRPr lang="en-US" sz="1350" dirty="0"/>
-          </a:p>
-        </p:txBody>
-      </p:sp>
-      <p:sp>
-        <p:nvSpPr>
-          <p:cNvPr id="25" name="Text 20"/>
-          <p:cNvSpPr txBox="1"/>
-          <p:nvPr/>
-        </p:nvSpPr>
-        <p:spPr>
-          <a:xfrm>
-            <a:off x="4480560" y="5577840"/>
-            <a:ext cx="3566160" cy="457200"/>
-          </a:xfrm>
-          <a:prstGeom prst="rect">
-            <a:avLst/>
-          </a:prstGeom>
-          <a:noFill/>
-          <a:ln/>
-        </p:spPr>
-        <p:txBody>
-          <a:bodyPr wrap="square" lIns="0" tIns="0" rIns="0" bIns="0" rtlCol="0" anchor="ctr"/>
+              <a:t>Small businesses</a:t>
+            </a:r>
+            <a:endParaRPr lang="en-US" sz="1500" dirty="0"/>
+          </a:p>
+        </p:txBody>
+      </p:sp>
+      <p:sp>
+        <p:nvSpPr>
+          <p:cNvPr id="26" name="Text 21"/>
+          <p:cNvSpPr txBox="1"/>
+          <p:nvPr/>
+        </p:nvSpPr>
+        <p:spPr>
+          <a:xfrm>
+            <a:off x="749808" y="5522976"/>
+            <a:ext cx="2377440" cy="658368"/>
+          </a:xfrm>
+          <a:prstGeom prst="rect">
+            <a:avLst/>
+          </a:prstGeom>
+          <a:noFill/>
+          <a:ln/>
+        </p:spPr>
+        <p:txBody>
+          <a:bodyPr wrap="square" lIns="0" tIns="0" rIns="0" bIns="0" rtlCol="0" anchor="t"/>
           <a:lstStyle/>
           <a:p>
             <a:pPr indent="0" marL="0">
               <a:buNone/>
             </a:pPr>
             <a:r>
-              <a:rPr lang="en-US" sz="1350" b="1" dirty="0">
-                <a:solidFill>
-                  <a:srgbClr val="FBBF24"/>
+              <a:rPr lang="en-US" sz="1200" dirty="0">
+                <a:solidFill>
+                  <a:srgbClr val="F8FAFC"/>
                 </a:solidFill>
                 <a:latin typeface="Calibri" pitchFamily="34" charset="0"/>
                 <a:ea typeface="Calibri" pitchFamily="34" charset="-122"/>
                 <a:cs typeface="Calibri" pitchFamily="34" charset="-120"/>
               </a:rPr>
-              <a:t>Suppliers  </a:t>
-            </a:r>
+              <a:t>Use it free, always.</a:t>
+            </a:r>
+            <a:endParaRPr lang="en-US" sz="1200" dirty="0"/>
+          </a:p>
+        </p:txBody>
+      </p:sp>
+      <p:sp>
+        <p:nvSpPr>
+          <p:cNvPr id="27" name="Shape 22"/>
+          <p:cNvSpPr/>
+          <p:nvPr/>
+        </p:nvSpPr>
+        <p:spPr>
+          <a:xfrm>
+            <a:off x="3429000" y="4846320"/>
+            <a:ext cx="4572000" cy="1371600"/>
+          </a:xfrm>
+          <a:prstGeom prst="roundRect">
+            <a:avLst>
+              <a:gd name="adj" fmla="val 8000"/>
+            </a:avLst>
+          </a:prstGeom>
+          <a:solidFill>
+            <a:srgbClr val="1E2B45"/>
+          </a:solidFill>
+          <a:ln w="12700">
+            <a:solidFill>
+              <a:srgbClr val="1E2B45"/>
+            </a:solidFill>
+            <a:prstDash val="solid"/>
+          </a:ln>
+        </p:spPr>
+      </p:sp>
+      <p:sp>
+        <p:nvSpPr>
+          <p:cNvPr id="28" name="Text 23"/>
+          <p:cNvSpPr txBox="1"/>
+          <p:nvPr/>
+        </p:nvSpPr>
+        <p:spPr>
+          <a:xfrm>
+            <a:off x="3630168" y="4937760"/>
+            <a:ext cx="4206240" cy="256032"/>
+          </a:xfrm>
+          <a:prstGeom prst="rect">
+            <a:avLst/>
+          </a:prstGeom>
+          <a:noFill/>
+          <a:ln/>
+        </p:spPr>
+        <p:txBody>
+          <a:bodyPr wrap="square" lIns="0" tIns="0" rIns="0" bIns="0" rtlCol="0" anchor="t"/>
+          <a:lstStyle/>
+          <a:p>
             <a:pPr indent="0" marL="0">
               <a:buNone/>
             </a:pPr>
             <a:r>
-              <a:rPr lang="en-US" sz="1350" dirty="0">
-                <a:solidFill>
-                  <a:srgbClr val="F8FAFC"/>
+              <a:rPr lang="en-US" sz="1050" b="1" spc="200" kern="0" dirty="0">
+                <a:solidFill>
+                  <a:srgbClr val="A3B3C9"/>
                 </a:solidFill>
                 <a:latin typeface="Calibri" pitchFamily="34" charset="0"/>
                 <a:ea typeface="Calibri" pitchFamily="34" charset="-122"/>
                 <a:cs typeface="Calibri" pitchFamily="34" charset="-120"/>
               </a:rPr>
-              <a:t>pay us: more orders, no cash lost on the road</a:t>
-            </a:r>
-            <a:endParaRPr lang="en-US" sz="1350" dirty="0"/>
-          </a:p>
-        </p:txBody>
-      </p:sp>
-      <p:sp>
-        <p:nvSpPr>
-          <p:cNvPr id="26" name="Text 21"/>
-          <p:cNvSpPr txBox="1"/>
-          <p:nvPr/>
-        </p:nvSpPr>
-        <p:spPr>
-          <a:xfrm>
-            <a:off x="8183880" y="5577840"/>
-            <a:ext cx="3566160" cy="457200"/>
-          </a:xfrm>
-          <a:prstGeom prst="rect">
-            <a:avLst/>
-          </a:prstGeom>
-          <a:noFill/>
-          <a:ln/>
-        </p:spPr>
-        <p:txBody>
-          <a:bodyPr wrap="square" lIns="0" tIns="0" rIns="0" bIns="0" rtlCol="0" anchor="ctr"/>
+              <a:t>CUSTOMERS</a:t>
+            </a:r>
+            <a:endParaRPr lang="en-US" sz="1050" dirty="0"/>
+          </a:p>
+        </p:txBody>
+      </p:sp>
+      <p:sp>
+        <p:nvSpPr>
+          <p:cNvPr id="29" name="Text 24"/>
+          <p:cNvSpPr txBox="1"/>
+          <p:nvPr/>
+        </p:nvSpPr>
+        <p:spPr>
+          <a:xfrm>
+            <a:off x="3630168" y="5175504"/>
+            <a:ext cx="4206240" cy="320040"/>
+          </a:xfrm>
+          <a:prstGeom prst="rect">
+            <a:avLst/>
+          </a:prstGeom>
+          <a:noFill/>
+          <a:ln/>
+        </p:spPr>
+        <p:txBody>
+          <a:bodyPr wrap="square" lIns="0" tIns="0" rIns="0" bIns="0" rtlCol="0" anchor="t"/>
           <a:lstStyle/>
           <a:p>
             <a:pPr indent="0" marL="0">
               <a:buNone/>
             </a:pPr>
             <a:r>
-              <a:rPr lang="en-US" sz="1350" b="1" dirty="0">
-                <a:solidFill>
-                  <a:srgbClr val="34D399"/>
+              <a:rPr lang="en-US" sz="1500" b="1" dirty="0">
+                <a:solidFill>
+                  <a:srgbClr val="FBBF24"/>
                 </a:solidFill>
                 <a:latin typeface="Calibri" pitchFamily="34" charset="0"/>
                 <a:ea typeface="Calibri" pitchFamily="34" charset="-122"/>
                 <a:cs typeface="Calibri" pitchFamily="34" charset="-120"/>
               </a:rPr>
-              <a:t>Banks and funds  </a:t>
-            </a:r>
+              <a:t>Suppliers</a:t>
+            </a:r>
+            <a:endParaRPr lang="en-US" sz="1500" dirty="0"/>
+          </a:p>
+        </p:txBody>
+      </p:sp>
+      <p:sp>
+        <p:nvSpPr>
+          <p:cNvPr id="30" name="Text 25"/>
+          <p:cNvSpPr txBox="1"/>
+          <p:nvPr/>
+        </p:nvSpPr>
+        <p:spPr>
+          <a:xfrm>
+            <a:off x="3630168" y="5522976"/>
+            <a:ext cx="4206240" cy="658368"/>
+          </a:xfrm>
+          <a:prstGeom prst="rect">
+            <a:avLst/>
+          </a:prstGeom>
+          <a:noFill/>
+          <a:ln/>
+        </p:spPr>
+        <p:txBody>
+          <a:bodyPr wrap="square" lIns="0" tIns="0" rIns="0" bIns="0" rtlCol="0" anchor="t"/>
+          <a:lstStyle/>
+          <a:p>
             <a:pPr indent="0" marL="0">
               <a:buNone/>
             </a:pPr>
             <a:r>
-              <a:rPr lang="en-US" sz="1350" dirty="0">
+              <a:rPr lang="en-US" sz="1200" dirty="0">
                 <a:solidFill>
                   <a:srgbClr val="F8FAFC"/>
                 </a:solidFill>
@@ -5137,15 +5240,159 @@
                 <a:ea typeface="Calibri" pitchFamily="34" charset="-122"/>
                 <a:cs typeface="Calibri" pitchFamily="34" charset="-120"/>
               </a:rPr>
-              <a:t>next, only with the owner's consent</a:t>
-            </a:r>
-            <a:endParaRPr lang="en-US" sz="1350" dirty="0"/>
+              <a:t>Pay a monthly fee for more orders from the businesses they already serve, paid up front, with no cash lost on the road.</a:t>
+            </a:r>
+            <a:endParaRPr lang="en-US" sz="1200" dirty="0"/>
+          </a:p>
+        </p:txBody>
+      </p:sp>
+      <p:sp>
+        <p:nvSpPr>
+          <p:cNvPr id="31" name="Shape 26"/>
+          <p:cNvSpPr/>
+          <p:nvPr/>
+        </p:nvSpPr>
+        <p:spPr>
+          <a:xfrm>
+            <a:off x="8138160" y="4846320"/>
+            <a:ext cx="3474720" cy="1371600"/>
+          </a:xfrm>
+          <a:prstGeom prst="roundRect">
+            <a:avLst>
+              <a:gd name="adj" fmla="val 8000"/>
+            </a:avLst>
+          </a:prstGeom>
+          <a:solidFill>
+            <a:srgbClr val="1E2B45"/>
+          </a:solidFill>
+          <a:ln w="12700">
+            <a:solidFill>
+              <a:srgbClr val="1E2B45"/>
+            </a:solidFill>
+            <a:prstDash val="solid"/>
+          </a:ln>
+        </p:spPr>
+      </p:sp>
+      <p:sp>
+        <p:nvSpPr>
+          <p:cNvPr id="32" name="Text 27"/>
+          <p:cNvSpPr txBox="1"/>
+          <p:nvPr/>
+        </p:nvSpPr>
+        <p:spPr>
+          <a:xfrm>
+            <a:off x="8339328" y="4937760"/>
+            <a:ext cx="3108960" cy="256032"/>
+          </a:xfrm>
+          <a:prstGeom prst="rect">
+            <a:avLst/>
+          </a:prstGeom>
+          <a:noFill/>
+          <a:ln/>
+        </p:spPr>
+        <p:txBody>
+          <a:bodyPr wrap="square" lIns="0" tIns="0" rIns="0" bIns="0" rtlCol="0" anchor="t"/>
+          <a:lstStyle/>
+          <a:p>
+            <a:pPr indent="0" marL="0">
+              <a:buNone/>
+            </a:pPr>
+            <a:r>
+              <a:rPr lang="en-US" sz="1050" b="1" spc="200" kern="0" dirty="0">
+                <a:solidFill>
+                  <a:srgbClr val="A3B3C9"/>
+                </a:solidFill>
+                <a:latin typeface="Calibri" pitchFamily="34" charset="0"/>
+                <a:ea typeface="Calibri" pitchFamily="34" charset="-122"/>
+                <a:cs typeface="Calibri" pitchFamily="34" charset="-120"/>
+              </a:rPr>
+              <a:t>TOMORROW</a:t>
+            </a:r>
+            <a:endParaRPr lang="en-US" sz="1050" dirty="0"/>
+          </a:p>
+        </p:txBody>
+      </p:sp>
+      <p:sp>
+        <p:nvSpPr>
+          <p:cNvPr id="33" name="Text 28"/>
+          <p:cNvSpPr txBox="1"/>
+          <p:nvPr/>
+        </p:nvSpPr>
+        <p:spPr>
+          <a:xfrm>
+            <a:off x="8339328" y="5175504"/>
+            <a:ext cx="3108960" cy="320040"/>
+          </a:xfrm>
+          <a:prstGeom prst="rect">
+            <a:avLst/>
+          </a:prstGeom>
+          <a:noFill/>
+          <a:ln/>
+        </p:spPr>
+        <p:txBody>
+          <a:bodyPr wrap="square" lIns="0" tIns="0" rIns="0" bIns="0" rtlCol="0" anchor="t"/>
+          <a:lstStyle/>
+          <a:p>
+            <a:pPr indent="0" marL="0">
+              <a:buNone/>
+            </a:pPr>
+            <a:r>
+              <a:rPr lang="en-US" sz="1500" b="1" dirty="0">
+                <a:solidFill>
+                  <a:srgbClr val="34D399"/>
+                </a:solidFill>
+                <a:latin typeface="Calibri" pitchFamily="34" charset="0"/>
+                <a:ea typeface="Calibri" pitchFamily="34" charset="-122"/>
+                <a:cs typeface="Calibri" pitchFamily="34" charset="-120"/>
+              </a:rPr>
+              <a:t>Banks and lenders</a:t>
+            </a:r>
+            <a:endParaRPr lang="en-US" sz="1500" dirty="0"/>
+          </a:p>
+        </p:txBody>
+      </p:sp>
+      <p:sp>
+        <p:nvSpPr>
+          <p:cNvPr id="34" name="Text 29"/>
+          <p:cNvSpPr txBox="1"/>
+          <p:nvPr/>
+        </p:nvSpPr>
+        <p:spPr>
+          <a:xfrm>
+            <a:off x="8339328" y="5522976"/>
+            <a:ext cx="3108960" cy="658368"/>
+          </a:xfrm>
+          <a:prstGeom prst="rect">
+            <a:avLst/>
+          </a:prstGeom>
+          <a:noFill/>
+          <a:ln/>
+        </p:spPr>
+        <p:txBody>
+          <a:bodyPr wrap="square" lIns="0" tIns="0" rIns="0" bIns="0" rtlCol="0" anchor="t"/>
+          <a:lstStyle/>
+          <a:p>
+            <a:pPr indent="0" marL="0">
+              <a:buNone/>
+            </a:pPr>
+            <a:r>
+              <a:rPr lang="en-US" sz="1200" dirty="0">
+                <a:solidFill>
+                  <a:srgbClr val="F8FAFC"/>
+                </a:solidFill>
+                <a:latin typeface="Calibri" pitchFamily="34" charset="0"/>
+                <a:ea typeface="Calibri" pitchFamily="34" charset="-122"/>
+                <a:cs typeface="Calibri" pitchFamily="34" charset="-120"/>
+              </a:rPr>
+              <a:t>Partnerships: a verified trading history they can trust, shared only with the owner's consent.</a:t>
+            </a:r>
+            <a:endParaRPr lang="en-US" sz="1200" dirty="0"/>
           </a:p>
         </p:txBody>
       </p:sp>
       <p:pic>
         <p:nvPicPr>
-          <p:cNvPr id="27" name="Image 3" descr="preencoded.png">    </p:cNvPr>
+          <p:cNvPr id="35" name="Image 3" descr="preencoded.png">    </p:cNvPr>
           <p:cNvPicPr>
             <a:picLocks noChangeAspect="1"/>
           </p:cNvPicPr>
@@ -5169,7 +5416,7 @@
       </p:pic>
       <p:sp>
         <p:nvSpPr>
-          <p:cNvPr id="28" name="Text 22"/>
+          <p:cNvPr id="36" name="Text 30"/>
           <p:cNvSpPr txBox="1"/>
           <p:nvPr/>
         </p:nvSpPr>
@@ -5203,6 +5450,45 @@
               <a:t>3</a:t>
             </a:r>
             <a:endParaRPr lang="en-US" sz="1000" dirty="0"/>
+          </a:p>
+        </p:txBody>
+      </p:sp>
+      <p:sp>
+        <p:nvSpPr>
+          <p:cNvPr id="37" name="Text 31"/>
+          <p:cNvSpPr txBox="1"/>
+          <p:nvPr/>
+        </p:nvSpPr>
+        <p:spPr>
+          <a:xfrm>
+            <a:off x="548640" y="6336792"/>
+            <a:ext cx="10241280" cy="365760"/>
+          </a:xfrm>
+          <a:prstGeom prst="rect">
+            <a:avLst/>
+          </a:prstGeom>
+          <a:noFill/>
+          <a:ln/>
+        </p:spPr>
+        <p:txBody>
+          <a:bodyPr wrap="square" lIns="0" tIns="0" rIns="0" bIns="0" rtlCol="0" anchor="t"/>
+          <a:lstStyle/>
+          <a:p>
+            <a:pPr indent="0" marL="0">
+              <a:buNone/>
+            </a:pPr>
+            <a:r>
+              <a:rPr lang="en-US" sz="950" dirty="0">
+                <a:solidFill>
+                  <a:srgbClr val="64748B"/>
+                </a:solidFill>
+                <a:latin typeface="Calibri" pitchFamily="34" charset="0"/>
+                <a:ea typeface="Calibri" pitchFamily="34" charset="-122"/>
+                <a:cs typeface="Calibri" pitchFamily="34" charset="-120"/>
+              </a:rPr>
+              <a:t>Honest limit: only digital payments count as proof, because the payment provider confirms the money moved. Cash and the business tools are the owner's own record.</a:t>
+            </a:r>
+            <a:endParaRPr lang="en-US" sz="950" dirty="0"/>
           </a:p>
         </p:txBody>
       </p:sp>
@@ -5325,7 +5611,7 @@
         <p:spPr>
           <a:xfrm>
             <a:off x="548640" y="1508760"/>
-            <a:ext cx="11064240" cy="457200"/>
+            <a:ext cx="11064240" cy="640080"/>
           </a:xfrm>
           <a:prstGeom prst="rect">
             <a:avLst/>
@@ -5341,7 +5627,7 @@
               <a:buNone/>
             </a:pPr>
             <a:r>
-              <a:rPr lang="en-US" sz="1700" i="1" dirty="0">
+              <a:rPr lang="en-US" sz="1600" i="1" dirty="0">
                 <a:solidFill>
                   <a:srgbClr val="A3B3C9"/>
                 </a:solidFill>
@@ -5349,9 +5635,9 @@
                 <a:ea typeface="Calibri" pitchFamily="34" charset="-122"/>
                 <a:cs typeface="Calibri" pitchFamily="34" charset="-120"/>
               </a:rPr>
-              <a:t>Thandi runs a small shop. She's busy, she trusts her customers, and she's never had a record of any of it.</a:t>
-            </a:r>
-            <a:endParaRPr lang="en-US" sz="1700" dirty="0"/>
+              <a:t>Thandi runs a small shop. Her customers pay her in cash, with no proof it moved. Where money can be proven is with her suppliers, so that's where Akayza starts.</a:t>
+            </a:r>
+            <a:endParaRPr lang="en-US" sz="1600" dirty="0"/>
           </a:p>
         </p:txBody>
       </p:sp>
@@ -5363,8 +5649,8 @@
         </p:nvSpPr>
         <p:spPr>
           <a:xfrm>
-            <a:off x="548640" y="2240280"/>
-            <a:ext cx="2606040" cy="3566160"/>
+            <a:off x="548640" y="2331720"/>
+            <a:ext cx="2606040" cy="3474720"/>
           </a:xfrm>
           <a:prstGeom prst="roundRect">
             <a:avLst>
@@ -5390,8 +5676,8 @@
         </p:nvSpPr>
         <p:spPr>
           <a:xfrm>
-            <a:off x="822960" y="2514600"/>
-            <a:ext cx="731520" cy="731520"/>
+            <a:off x="822960" y="2578608"/>
+            <a:ext cx="713232" cy="713232"/>
           </a:xfrm>
           <a:prstGeom prst="ellipse">
             <a:avLst/>
@@ -5423,8 +5709,8 @@
         </p:blipFill>
         <p:spPr>
           <a:xfrm>
-            <a:off x="998525" y="2690165"/>
-            <a:ext cx="380390" cy="380390"/>
+            <a:off x="994136" y="2749784"/>
+            <a:ext cx="370881" cy="370881"/>
           </a:xfrm>
           <a:prstGeom prst="rect">
             <a:avLst/>
@@ -5439,7 +5725,7 @@
         </p:nvSpPr>
         <p:spPr>
           <a:xfrm>
-            <a:off x="822960" y="3429000"/>
+            <a:off x="822960" y="3474720"/>
             <a:ext cx="2194560" cy="320040"/>
           </a:xfrm>
           <a:prstGeom prst="rect">
@@ -5478,8 +5764,8 @@
         </p:nvSpPr>
         <p:spPr>
           <a:xfrm>
-            <a:off x="822960" y="3794760"/>
-            <a:ext cx="2148840" cy="731520"/>
+            <a:off x="822960" y="3822192"/>
+            <a:ext cx="2148840" cy="685800"/>
           </a:xfrm>
           <a:prstGeom prst="rect">
             <a:avLst/>
@@ -5495,7 +5781,7 @@
               <a:buNone/>
             </a:pPr>
             <a:r>
-              <a:rPr lang="en-US" sz="1800" b="1" dirty="0">
+              <a:rPr lang="en-US" sz="1700" b="1" dirty="0">
                 <a:solidFill>
                   <a:srgbClr val="F8FAFC"/>
                 </a:solidFill>
@@ -5505,7 +5791,7 @@
               </a:rPr>
               <a:t>Restocks in 2 minutes</a:t>
             </a:r>
-            <a:endParaRPr lang="en-US" sz="1800" dirty="0"/>
+            <a:endParaRPr lang="en-US" sz="1700" dirty="0"/>
           </a:p>
         </p:txBody>
       </p:sp>
@@ -5517,7 +5803,7 @@
         </p:nvSpPr>
         <p:spPr>
           <a:xfrm>
-            <a:off x="822960" y="4572000"/>
+            <a:off x="822960" y="4553712"/>
             <a:ext cx="2148840" cy="1188720"/>
           </a:xfrm>
           <a:prstGeom prst="rect">
@@ -5556,7 +5842,7 @@
         </p:nvSpPr>
         <p:spPr>
           <a:xfrm>
-            <a:off x="3182112" y="4023360"/>
+            <a:off x="3182112" y="4069080"/>
             <a:ext cx="164592" cy="0"/>
           </a:xfrm>
           <a:prstGeom prst="line">
@@ -5580,8 +5866,8 @@
         </p:nvSpPr>
         <p:spPr>
           <a:xfrm>
-            <a:off x="3364992" y="2240280"/>
-            <a:ext cx="2606040" cy="3566160"/>
+            <a:off x="3364992" y="2331720"/>
+            <a:ext cx="2606040" cy="3474720"/>
           </a:xfrm>
           <a:prstGeom prst="roundRect">
             <a:avLst>
@@ -5607,8 +5893,8 @@
         </p:nvSpPr>
         <p:spPr>
           <a:xfrm>
-            <a:off x="3639312" y="2514600"/>
-            <a:ext cx="731520" cy="731520"/>
+            <a:off x="3639312" y="2578608"/>
+            <a:ext cx="713232" cy="713232"/>
           </a:xfrm>
           <a:prstGeom prst="ellipse">
             <a:avLst/>
@@ -5640,8 +5926,8 @@
         </p:blipFill>
         <p:spPr>
           <a:xfrm>
-            <a:off x="3814877" y="2690165"/>
-            <a:ext cx="380390" cy="380390"/>
+            <a:off x="3810488" y="2749784"/>
+            <a:ext cx="370881" cy="370881"/>
           </a:xfrm>
           <a:prstGeom prst="rect">
             <a:avLst/>
@@ -5656,7 +5942,7 @@
         </p:nvSpPr>
         <p:spPr>
           <a:xfrm>
-            <a:off x="3639312" y="3429000"/>
+            <a:off x="3639312" y="3474720"/>
             <a:ext cx="2194560" cy="320040"/>
           </a:xfrm>
           <a:prstGeom prst="rect">
@@ -5695,8 +5981,8 @@
         </p:nvSpPr>
         <p:spPr>
           <a:xfrm>
-            <a:off x="3639312" y="3794760"/>
-            <a:ext cx="2148840" cy="731520"/>
+            <a:off x="3639312" y="3822192"/>
+            <a:ext cx="2148840" cy="685800"/>
           </a:xfrm>
           <a:prstGeom prst="rect">
             <a:avLst/>
@@ -5712,7 +5998,7 @@
               <a:buNone/>
             </a:pPr>
             <a:r>
-              <a:rPr lang="en-US" sz="1800" b="1" dirty="0">
+              <a:rPr lang="en-US" sz="1700" b="1" dirty="0">
                 <a:solidFill>
                   <a:srgbClr val="F8FAFC"/>
                 </a:solidFill>
@@ -5720,9 +6006,9 @@
                 <a:ea typeface="Calibri" pitchFamily="34" charset="-122"/>
                 <a:cs typeface="Calibri" pitchFamily="34" charset="-120"/>
               </a:rPr>
-              <a:t>Gets paid back</a:t>
-            </a:r>
-            <a:endParaRPr lang="en-US" sz="1800" dirty="0"/>
+              <a:t>Records a repayment</a:t>
+            </a:r>
+            <a:endParaRPr lang="en-US" sz="1700" dirty="0"/>
           </a:p>
         </p:txBody>
       </p:sp>
@@ -5734,7 +6020,7 @@
         </p:nvSpPr>
         <p:spPr>
           <a:xfrm>
-            <a:off x="3639312" y="4572000"/>
+            <a:off x="3639312" y="4553712"/>
             <a:ext cx="2148840" cy="1188720"/>
           </a:xfrm>
           <a:prstGeom prst="rect">
@@ -5759,7 +6045,7 @@
                 <a:ea typeface="Calibri" pitchFamily="34" charset="-122"/>
                 <a:cs typeface="Calibri" pitchFamily="34" charset="-120"/>
               </a:rPr>
-              <a:t>A customer settles his credit. It's off her book on the spot.</a:t>
+              <a:t>A customer settles his credit. She records it in her credit book, one of her business tools.</a:t>
             </a:r>
             <a:endParaRPr lang="en-US" sz="1350" dirty="0"/>
           </a:p>
@@ -5773,7 +6059,7 @@
         </p:nvSpPr>
         <p:spPr>
           <a:xfrm>
-            <a:off x="5998464" y="4023360"/>
+            <a:off x="5998464" y="4069080"/>
             <a:ext cx="164592" cy="0"/>
           </a:xfrm>
           <a:prstGeom prst="line">
@@ -5797,8 +6083,8 @@
         </p:nvSpPr>
         <p:spPr>
           <a:xfrm>
-            <a:off x="6181344" y="2240280"/>
-            <a:ext cx="2606040" cy="3566160"/>
+            <a:off x="6181344" y="2331720"/>
+            <a:ext cx="2606040" cy="3474720"/>
           </a:xfrm>
           <a:prstGeom prst="roundRect">
             <a:avLst>
@@ -5824,8 +6110,8 @@
         </p:nvSpPr>
         <p:spPr>
           <a:xfrm>
-            <a:off x="6455664" y="2514600"/>
-            <a:ext cx="731520" cy="731520"/>
+            <a:off x="6455664" y="2578608"/>
+            <a:ext cx="713232" cy="713232"/>
           </a:xfrm>
           <a:prstGeom prst="ellipse">
             <a:avLst/>
@@ -5857,8 +6143,8 @@
         </p:blipFill>
         <p:spPr>
           <a:xfrm>
-            <a:off x="6631229" y="2690165"/>
-            <a:ext cx="380390" cy="380390"/>
+            <a:off x="6626840" y="2749784"/>
+            <a:ext cx="370881" cy="370881"/>
           </a:xfrm>
           <a:prstGeom prst="rect">
             <a:avLst/>
@@ -5873,7 +6159,7 @@
         </p:nvSpPr>
         <p:spPr>
           <a:xfrm>
-            <a:off x="6455664" y="3429000"/>
+            <a:off x="6455664" y="3474720"/>
             <a:ext cx="2194560" cy="320040"/>
           </a:xfrm>
           <a:prstGeom prst="rect">
@@ -5912,8 +6198,8 @@
         </p:nvSpPr>
         <p:spPr>
           <a:xfrm>
-            <a:off x="6455664" y="3794760"/>
-            <a:ext cx="2148840" cy="731520"/>
+            <a:off x="6455664" y="3822192"/>
+            <a:ext cx="2148840" cy="685800"/>
           </a:xfrm>
           <a:prstGeom prst="rect">
             <a:avLst/>
@@ -5929,7 +6215,7 @@
               <a:buNone/>
             </a:pPr>
             <a:r>
-              <a:rPr lang="en-US" sz="1800" b="1" dirty="0">
+              <a:rPr lang="en-US" sz="1700" b="1" dirty="0">
                 <a:solidFill>
                   <a:srgbClr val="F8FAFC"/>
                 </a:solidFill>
@@ -5939,7 +6225,7 @@
               </a:rPr>
               <a:t>Pays without cash risk</a:t>
             </a:r>
-            <a:endParaRPr lang="en-US" sz="1800" dirty="0"/>
+            <a:endParaRPr lang="en-US" sz="1700" dirty="0"/>
           </a:p>
         </p:txBody>
       </p:sp>
@@ -5951,7 +6237,7 @@
         </p:nvSpPr>
         <p:spPr>
           <a:xfrm>
-            <a:off x="6455664" y="4572000"/>
+            <a:off x="6455664" y="4553712"/>
             <a:ext cx="2148840" cy="1188720"/>
           </a:xfrm>
           <a:prstGeom prst="rect">
@@ -5990,7 +6276,7 @@
         </p:nvSpPr>
         <p:spPr>
           <a:xfrm>
-            <a:off x="8814816" y="4023360"/>
+            <a:off x="8814816" y="4069080"/>
             <a:ext cx="164592" cy="0"/>
           </a:xfrm>
           <a:prstGeom prst="line">
@@ -6014,8 +6300,8 @@
         </p:nvSpPr>
         <p:spPr>
           <a:xfrm>
-            <a:off x="8997696" y="2240280"/>
-            <a:ext cx="2606040" cy="3566160"/>
+            <a:off x="8997696" y="2331720"/>
+            <a:ext cx="2606040" cy="3474720"/>
           </a:xfrm>
           <a:prstGeom prst="roundRect">
             <a:avLst>
@@ -6041,8 +6327,8 @@
         </p:nvSpPr>
         <p:spPr>
           <a:xfrm>
-            <a:off x="9272016" y="2514600"/>
-            <a:ext cx="731520" cy="731520"/>
+            <a:off x="9272016" y="2578608"/>
+            <a:ext cx="713232" cy="713232"/>
           </a:xfrm>
           <a:prstGeom prst="ellipse">
             <a:avLst/>
@@ -6074,8 +6360,8 @@
         </p:blipFill>
         <p:spPr>
           <a:xfrm>
-            <a:off x="9447581" y="2690165"/>
-            <a:ext cx="380390" cy="380390"/>
+            <a:off x="9443192" y="2749784"/>
+            <a:ext cx="370881" cy="370881"/>
           </a:xfrm>
           <a:prstGeom prst="rect">
             <a:avLst/>
@@ -6090,7 +6376,7 @@
         </p:nvSpPr>
         <p:spPr>
           <a:xfrm>
-            <a:off x="9272016" y="3429000"/>
+            <a:off x="9272016" y="3474720"/>
             <a:ext cx="2194560" cy="320040"/>
           </a:xfrm>
           <a:prstGeom prst="rect">
@@ -6129,8 +6415,8 @@
         </p:nvSpPr>
         <p:spPr>
           <a:xfrm>
-            <a:off x="9272016" y="3794760"/>
-            <a:ext cx="2148840" cy="731520"/>
+            <a:off x="9272016" y="3822192"/>
+            <a:ext cx="2148840" cy="685800"/>
           </a:xfrm>
           <a:prstGeom prst="rect">
             <a:avLst/>
@@ -6146,7 +6432,7 @@
               <a:buNone/>
             </a:pPr>
             <a:r>
-              <a:rPr lang="en-US" sz="1800" b="1" dirty="0">
+              <a:rPr lang="en-US" sz="1700" b="1" dirty="0">
                 <a:solidFill>
                   <a:srgbClr val="F8FAFC"/>
                 </a:solidFill>
@@ -6156,7 +6442,7 @@
               </a:rPr>
               <a:t>Sees her business</a:t>
             </a:r>
-            <a:endParaRPr lang="en-US" sz="1800" dirty="0"/>
+            <a:endParaRPr lang="en-US" sz="1700" dirty="0"/>
           </a:p>
         </p:txBody>
       </p:sp>
@@ -6168,7 +6454,7 @@
         </p:nvSpPr>
         <p:spPr>
           <a:xfrm>
-            <a:off x="9272016" y="4572000"/>
+            <a:off x="9272016" y="4553712"/>
             <a:ext cx="2148840" cy="1188720"/>
           </a:xfrm>
           <a:prstGeom prst="rect">
@@ -6193,7 +6479,7 @@
                 <a:ea typeface="Calibri" pitchFamily="34" charset="-122"/>
                 <a:cs typeface="Calibri" pitchFamily="34" charset="-120"/>
               </a:rPr>
-              <a:t>What she sold, what she's owed, what she bought. She seals it, and it's hers.</a:t>
+              <a:t>Who owes her, what she orders most and how often, and the suppliers that fit how she buys.</a:t>
             </a:r>
             <a:endParaRPr lang="en-US" sz="1350" dirty="0"/>
           </a:p>
@@ -6232,7 +6518,7 @@
                 <a:ea typeface="Calibri" pitchFamily="34" charset="-122"/>
                 <a:cs typeface="Calibri" pitchFamily="34" charset="-120"/>
               </a:rPr>
-              <a:t>Sipho the builder has the same week: stock for the site, jobs in stages, the client signs off each stage from a link.</a:t>
+              <a:t>Same week for Sipho the builder: materials for the site from his suppliers, jobs tracked in stages.</a:t>
             </a:r>
             <a:endParaRPr lang="en-US" sz="1400" dirty="0"/>
           </a:p>

</xml_diff>

<commit_message>
Deck slides 5 and 7: two-way go-to-market, scattered supplier calls vs all suppliers in one place, business tools, sharper edges
Co-Authored-By: Claude Opus 5.5 <noreply@anthropic.com>
Claude-Session: https://claude.ai/code/session_01W9vcEkUR51B1hgQFTnjcUh
</commit_message>
<xml_diff>
--- a/docs/submission/05_final_submission/Akayza_Pitch_TeamPR.pptx
+++ b/docs/submission/05_final_submission/Akayza_Pitch_TeamPR.pptx
@@ -1954,7 +1954,7 @@
           <a:p>
             <a:r>
               <a:rPr lang="en-US" dirty="0"/>
-              <a:t>SAY (25 s): 'The township economy is R900 billion a year; spaza shops alone move R180 billion. And 56% already prefer EFT: that's why South Africa first. Suppliers pay us, businesses never do: R299 or R1,499 a month, and about 1% only on digital orders, never on cash. We don't chase businesses one by one: we sign a supplier, and it brings the businesses it already delivers to. End of year one, about R56,000 a month; year three, about R1.1 million.'
+              <a:t>SAY (25 s): 'Our users are small and informal businesses; they use it free. Our customers are suppliers. The township economy is R900 billion a year; spaza shops alone move R180 billion. And 56% already prefer EFT: that's why South Africa first. Suppliers pay us, businesses never do: R299 or R1,499 a month, and about 1% only on digital orders, never on cash. We don't chase businesses one by one: we sign a supplier, and it brings the businesses it already delivers to. And businesses invite the suppliers they already order from. End of year one, about R56,000 a month; year three, about R1.1 million.'
 WHY SA FIRST (if asked): we live it; big and dense (one supplier route serves hundreds of businesses); ready for digital; clear rules (POPIA, CIPC, VAT). Then the rest of Africa.
 HOW the revenue works: subscriptions = supplier mix × price; commission = active businesses × ~R4,000 digital orders a month × 1%. Year 1: 5 Starter + 10 Pro suppliers, 1,000 businesses. Estimates, and we say so.</a:t>
             </a:r>
@@ -2136,7 +2136,7 @@
             <a:r>
               <a:rPr lang="en-US" dirty="0"/>
               <a:t>SAY (20 s): 'Everyone serves a slice. A wholesaler's own app, like Shoprite Cash &amp; Carry's, sells its own range. Payment apps take card payments. We serve the whole business, with the suppliers it already uses, for any kind of business. It gets smarter with use, and it builds a record that holds up.'
-Our biggest competitor is the habit of WhatsApp and a notebook. Don't attack anyone; show the gap. We complement payment apps; we don't replace them. We're not a marketplace: we recommend suppliers, never products.</a:t>
+Our biggest competitor is the habit: calls, voice notes and WhatsApp messages to different suppliers, nothing in one place, nothing to track. Then a notebook. Don't attack anyone; show the gap. We complement payment apps; we don't replace them. We're not a marketplace: we recommend suppliers, never products.</a:t>
             </a:r>
             <a:endParaRPr lang="en-US" dirty="0"/>
           </a:p>
@@ -6691,7 +6691,7 @@
                 <a:ea typeface="Georgia" pitchFamily="34" charset="-122"/>
                 <a:cs typeface="Georgia" pitchFamily="34" charset="-120"/>
               </a:rPr>
-              <a:t>Suppliers pay. Businesses never do.</a:t>
+              <a:t>Suppliers pay. Businesses use it free.</a:t>
             </a:r>
             <a:endParaRPr lang="en-US" sz="3200" dirty="0"/>
           </a:p>
@@ -6966,8 +6966,8 @@
         </p:nvSpPr>
         <p:spPr>
           <a:xfrm>
-            <a:off x="777240" y="5047488"/>
-            <a:ext cx="4572000" cy="1005840"/>
+            <a:off x="777240" y="5001768"/>
+            <a:ext cx="4572000" cy="1078992"/>
           </a:xfrm>
           <a:prstGeom prst="rect">
             <a:avLst/>
@@ -6983,7 +6983,7 @@
               <a:buNone/>
             </a:pPr>
             <a:r>
-              <a:rPr lang="en-US" sz="1350" b="1" dirty="0">
+              <a:rPr lang="en-US" sz="1250" b="1" dirty="0">
                 <a:solidFill>
                   <a:srgbClr val="FBBF24"/>
                 </a:solidFill>
@@ -6997,7 +6997,7 @@
               <a:buNone/>
             </a:pPr>
             <a:r>
-              <a:rPr lang="en-US" sz="1350" dirty="0">
+              <a:rPr lang="en-US" sz="1250" dirty="0">
                 <a:solidFill>
                   <a:srgbClr val="F8FAFC"/>
                 </a:solidFill>
@@ -7005,9 +7005,9 @@
                 <a:ea typeface="Calibri" pitchFamily="34" charset="-122"/>
                 <a:cs typeface="Calibri" pitchFamily="34" charset="-120"/>
               </a:rPr>
-              <a:t>Sign a supplier, and it brings the businesses it already delivers to. 2 suppliers in the pilot, 15 in year 1, 200 by year 3.</a:t>
-            </a:r>
-            <a:endParaRPr lang="en-US" sz="1350" dirty="0"/>
+              <a:t>Two ways in. Sign a supplier, and it brings the businesses it delivers to. Businesses invite the suppliers they already order from. 2 suppliers in the pilot, 15 in year 1, 200 by year 3.</a:t>
+            </a:r>
+            <a:endParaRPr lang="en-US" sz="1250" dirty="0"/>
           </a:p>
         </p:txBody>
       </p:sp>
@@ -8897,7 +8897,7 @@
                 <a:gridCol w="1828800"/>
                 <a:gridCol w="1828800"/>
               </a:tblGrid>
-              <a:tr h="585216">
+              <a:tr h="548640">
                 <a:tc>
                   <a:txBody>
                     <a:bodyPr/>
@@ -8906,7 +8906,7 @@
                       <a:pPr algn="l" indent="0" marL="0">
                         <a:buNone/>
                       </a:pPr>
-                      <a:endParaRPr lang="en-US" sz="1350" dirty="0">
+                      <a:endParaRPr lang="en-US" sz="1250" dirty="0">
                         <a:latin typeface="Calibri" charset="0"/>
                         <a:ea typeface="Calibri" charset="0"/>
                         <a:cs typeface="Calibri" charset="0"/>
@@ -8964,7 +8964,7 @@
                         <a:buNone/>
                       </a:pPr>
                       <a:r>
-                        <a:rPr lang="en-US" sz="1350" b="1" dirty="0">
+                        <a:rPr lang="en-US" sz="1250" b="1" dirty="0">
                           <a:solidFill>
                             <a:srgbClr val="34D399"/>
                           </a:solidFill>
@@ -8974,7 +8974,7 @@
                         </a:rPr>
                         <a:t>Runs the business</a:t>
                       </a:r>
-                      <a:endParaRPr lang="en-US" sz="1350" dirty="0">
+                      <a:endParaRPr lang="en-US" sz="1250" dirty="0">
                         <a:latin typeface="Calibri" charset="0"/>
                         <a:ea typeface="Calibri" charset="0"/>
                         <a:cs typeface="Calibri" charset="0"/>
@@ -9032,7 +9032,7 @@
                         <a:buNone/>
                       </a:pPr>
                       <a:r>
-                        <a:rPr lang="en-US" sz="1350" b="1" dirty="0">
+                        <a:rPr lang="en-US" sz="1250" b="1" dirty="0">
                           <a:solidFill>
                             <a:srgbClr val="34D399"/>
                           </a:solidFill>
@@ -9042,7 +9042,7 @@
                         </a:rPr>
                         <a:t>Your own suppliers</a:t>
                       </a:r>
-                      <a:endParaRPr lang="en-US" sz="1350" dirty="0">
+                      <a:endParaRPr lang="en-US" sz="1250" dirty="0">
                         <a:latin typeface="Calibri" charset="0"/>
                         <a:ea typeface="Calibri" charset="0"/>
                         <a:cs typeface="Calibri" charset="0"/>
@@ -9100,7 +9100,7 @@
                         <a:buNone/>
                       </a:pPr>
                       <a:r>
-                        <a:rPr lang="en-US" sz="1350" b="1" dirty="0">
+                        <a:rPr lang="en-US" sz="1250" b="1" dirty="0">
                           <a:solidFill>
                             <a:srgbClr val="34D399"/>
                           </a:solidFill>
@@ -9110,7 +9110,7 @@
                         </a:rPr>
                         <a:t>Any kind of business</a:t>
                       </a:r>
-                      <a:endParaRPr lang="en-US" sz="1350" dirty="0">
+                      <a:endParaRPr lang="en-US" sz="1250" dirty="0">
                         <a:latin typeface="Calibri" charset="0"/>
                         <a:ea typeface="Calibri" charset="0"/>
                         <a:cs typeface="Calibri" charset="0"/>
@@ -9168,7 +9168,7 @@
                         <a:buNone/>
                       </a:pPr>
                       <a:r>
-                        <a:rPr lang="en-US" sz="1350" b="1" dirty="0">
+                        <a:rPr lang="en-US" sz="1250" b="1" dirty="0">
                           <a:solidFill>
                             <a:srgbClr val="34D399"/>
                           </a:solidFill>
@@ -9178,7 +9178,7 @@
                         </a:rPr>
                         <a:t>Verified payment</a:t>
                       </a:r>
-                      <a:endParaRPr lang="en-US" sz="1350" dirty="0">
+                      <a:endParaRPr lang="en-US" sz="1250" dirty="0">
                         <a:latin typeface="Calibri" charset="0"/>
                         <a:ea typeface="Calibri" charset="0"/>
                         <a:cs typeface="Calibri" charset="0"/>
@@ -9228,7 +9228,7 @@
                   </a:tcPr>
                 </a:tc>
               </a:tr>
-              <a:tr h="585216">
+              <a:tr h="548640">
                 <a:tc>
                   <a:txBody>
                     <a:bodyPr/>
@@ -9238,7 +9238,7 @@
                         <a:buNone/>
                       </a:pPr>
                       <a:r>
-                        <a:rPr lang="en-US" sz="1350" b="1" dirty="0">
+                        <a:rPr lang="en-US" sz="1250" b="1" dirty="0">
                           <a:solidFill>
                             <a:srgbClr val="F8FAFC"/>
                           </a:solidFill>
@@ -9246,9 +9246,9 @@
                           <a:ea typeface="Calibri" pitchFamily="34" charset="-122"/>
                           <a:cs typeface="Calibri" pitchFamily="34" charset="-120"/>
                         </a:rPr>
-                        <a:t>WhatsApp + notebook (today)</a:t>
+                        <a:t>WhatsApp, calls + a notebook (today)</a:t>
                       </a:r>
-                      <a:endParaRPr lang="en-US" sz="1350" dirty="0">
+                      <a:endParaRPr lang="en-US" sz="1250" dirty="0">
                         <a:latin typeface="Calibri" charset="0"/>
                         <a:ea typeface="Calibri" charset="0"/>
                         <a:cs typeface="Calibri" charset="0"/>
@@ -9306,7 +9306,7 @@
                         <a:buNone/>
                       </a:pPr>
                       <a:r>
-                        <a:rPr lang="en-US" sz="1350" dirty="0">
+                        <a:rPr lang="en-US" sz="1250" dirty="0">
                           <a:solidFill>
                             <a:srgbClr val="64748B"/>
                           </a:solidFill>
@@ -9316,7 +9316,7 @@
                         </a:rPr>
                         <a:t>no</a:t>
                       </a:r>
-                      <a:endParaRPr lang="en-US" sz="1350" dirty="0">
+                      <a:endParaRPr lang="en-US" sz="1250" dirty="0">
                         <a:latin typeface="Calibri" charset="0"/>
                         <a:ea typeface="Calibri" charset="0"/>
                         <a:cs typeface="Calibri" charset="0"/>
@@ -9374,7 +9374,7 @@
                         <a:buNone/>
                       </a:pPr>
                       <a:r>
-                        <a:rPr lang="en-US" sz="1350" dirty="0">
+                        <a:rPr lang="en-US" sz="1250" dirty="0">
                           <a:solidFill>
                             <a:srgbClr val="F8FAFC"/>
                           </a:solidFill>
@@ -9382,9 +9382,9 @@
                           <a:ea typeface="Calibri" pitchFamily="34" charset="-122"/>
                           <a:cs typeface="Calibri" pitchFamily="34" charset="-120"/>
                         </a:rPr>
-                        <a:t>by voice note</a:t>
+                        <a:t>scattered: calls, voice notes</a:t>
                       </a:r>
-                      <a:endParaRPr lang="en-US" sz="1350" dirty="0">
+                      <a:endParaRPr lang="en-US" sz="1250" dirty="0">
                         <a:latin typeface="Calibri" charset="0"/>
                         <a:ea typeface="Calibri" charset="0"/>
                         <a:cs typeface="Calibri" charset="0"/>
@@ -9442,7 +9442,7 @@
                         <a:buNone/>
                       </a:pPr>
                       <a:r>
-                        <a:rPr lang="en-US" sz="1350" dirty="0">
+                        <a:rPr lang="en-US" sz="1250" dirty="0">
                           <a:solidFill>
                             <a:srgbClr val="F8FAFC"/>
                           </a:solidFill>
@@ -9452,7 +9452,7 @@
                         </a:rPr>
                         <a:t>yes</a:t>
                       </a:r>
-                      <a:endParaRPr lang="en-US" sz="1350" dirty="0">
+                      <a:endParaRPr lang="en-US" sz="1250" dirty="0">
                         <a:latin typeface="Calibri" charset="0"/>
                         <a:ea typeface="Calibri" charset="0"/>
                         <a:cs typeface="Calibri" charset="0"/>
@@ -9510,7 +9510,7 @@
                         <a:buNone/>
                       </a:pPr>
                       <a:r>
-                        <a:rPr lang="en-US" sz="1350" dirty="0">
+                        <a:rPr lang="en-US" sz="1250" dirty="0">
                           <a:solidFill>
                             <a:srgbClr val="64748B"/>
                           </a:solidFill>
@@ -9520,7 +9520,7 @@
                         </a:rPr>
                         <a:t>no</a:t>
                       </a:r>
-                      <a:endParaRPr lang="en-US" sz="1350" dirty="0">
+                      <a:endParaRPr lang="en-US" sz="1250" dirty="0">
                         <a:latin typeface="Calibri" charset="0"/>
                         <a:ea typeface="Calibri" charset="0"/>
                         <a:cs typeface="Calibri" charset="0"/>
@@ -9570,7 +9570,7 @@
                   </a:tcPr>
                 </a:tc>
               </a:tr>
-              <a:tr h="585216">
+              <a:tr h="548640">
                 <a:tc>
                   <a:txBody>
                     <a:bodyPr/>
@@ -9580,7 +9580,7 @@
                         <a:buNone/>
                       </a:pPr>
                       <a:r>
-                        <a:rPr lang="en-US" sz="1350" b="1" dirty="0">
+                        <a:rPr lang="en-US" sz="1250" b="1" dirty="0">
                           <a:solidFill>
                             <a:srgbClr val="F8FAFC"/>
                           </a:solidFill>
@@ -9590,7 +9590,7 @@
                         </a:rPr>
                         <a:t>A wholesaler's own app (e.g. Shoprite Cash &amp; Carry)</a:t>
                       </a:r>
-                      <a:endParaRPr lang="en-US" sz="1350" dirty="0">
+                      <a:endParaRPr lang="en-US" sz="1250" dirty="0">
                         <a:latin typeface="Calibri" charset="0"/>
                         <a:ea typeface="Calibri" charset="0"/>
                         <a:cs typeface="Calibri" charset="0"/>
@@ -9648,7 +9648,7 @@
                         <a:buNone/>
                       </a:pPr>
                       <a:r>
-                        <a:rPr lang="en-US" sz="1350" dirty="0">
+                        <a:rPr lang="en-US" sz="1250" dirty="0">
                           <a:solidFill>
                             <a:srgbClr val="64748B"/>
                           </a:solidFill>
@@ -9658,7 +9658,7 @@
                         </a:rPr>
                         <a:t>no</a:t>
                       </a:r>
-                      <a:endParaRPr lang="en-US" sz="1350" dirty="0">
+                      <a:endParaRPr lang="en-US" sz="1250" dirty="0">
                         <a:latin typeface="Calibri" charset="0"/>
                         <a:ea typeface="Calibri" charset="0"/>
                         <a:cs typeface="Calibri" charset="0"/>
@@ -9716,7 +9716,7 @@
                         <a:buNone/>
                       </a:pPr>
                       <a:r>
-                        <a:rPr lang="en-US" sz="1350" dirty="0">
+                        <a:rPr lang="en-US" sz="1250" dirty="0">
                           <a:solidFill>
                             <a:srgbClr val="F8FAFC"/>
                           </a:solidFill>
@@ -9726,7 +9726,7 @@
                         </a:rPr>
                         <a:t>one wholesaler</a:t>
                       </a:r>
-                      <a:endParaRPr lang="en-US" sz="1350" dirty="0">
+                      <a:endParaRPr lang="en-US" sz="1250" dirty="0">
                         <a:latin typeface="Calibri" charset="0"/>
                         <a:ea typeface="Calibri" charset="0"/>
                         <a:cs typeface="Calibri" charset="0"/>
@@ -9784,7 +9784,7 @@
                         <a:buNone/>
                       </a:pPr>
                       <a:r>
-                        <a:rPr lang="en-US" sz="1350" dirty="0">
+                        <a:rPr lang="en-US" sz="1250" dirty="0">
                           <a:solidFill>
                             <a:srgbClr val="F8FAFC"/>
                           </a:solidFill>
@@ -9794,7 +9794,7 @@
                         </a:rPr>
                         <a:t>shops</a:t>
                       </a:r>
-                      <a:endParaRPr lang="en-US" sz="1350" dirty="0">
+                      <a:endParaRPr lang="en-US" sz="1250" dirty="0">
                         <a:latin typeface="Calibri" charset="0"/>
                         <a:ea typeface="Calibri" charset="0"/>
                         <a:cs typeface="Calibri" charset="0"/>
@@ -9852,7 +9852,7 @@
                         <a:buNone/>
                       </a:pPr>
                       <a:r>
-                        <a:rPr lang="en-US" sz="1350" dirty="0">
+                        <a:rPr lang="en-US" sz="1250" dirty="0">
                           <a:solidFill>
                             <a:srgbClr val="F8FAFC"/>
                           </a:solidFill>
@@ -9862,7 +9862,7 @@
                         </a:rPr>
                         <a:t>yes</a:t>
                       </a:r>
-                      <a:endParaRPr lang="en-US" sz="1350" dirty="0">
+                      <a:endParaRPr lang="en-US" sz="1250" dirty="0">
                         <a:latin typeface="Calibri" charset="0"/>
                         <a:ea typeface="Calibri" charset="0"/>
                         <a:cs typeface="Calibri" charset="0"/>
@@ -9912,7 +9912,7 @@
                   </a:tcPr>
                 </a:tc>
               </a:tr>
-              <a:tr h="585216">
+              <a:tr h="548640">
                 <a:tc>
                   <a:txBody>
                     <a:bodyPr/>
@@ -9922,7 +9922,7 @@
                         <a:buNone/>
                       </a:pPr>
                       <a:r>
-                        <a:rPr lang="en-US" sz="1350" b="1" dirty="0">
+                        <a:rPr lang="en-US" sz="1250" b="1" dirty="0">
                           <a:solidFill>
                             <a:srgbClr val="F8FAFC"/>
                           </a:solidFill>
@@ -9932,7 +9932,7 @@
                         </a:rPr>
                         <a:t>Payments / POS (iKhokha, Yoco)</a:t>
                       </a:r>
-                      <a:endParaRPr lang="en-US" sz="1350" dirty="0">
+                      <a:endParaRPr lang="en-US" sz="1250" dirty="0">
                         <a:latin typeface="Calibri" charset="0"/>
                         <a:ea typeface="Calibri" charset="0"/>
                         <a:cs typeface="Calibri" charset="0"/>
@@ -9990,7 +9990,7 @@
                         <a:buNone/>
                       </a:pPr>
                       <a:r>
-                        <a:rPr lang="en-US" sz="1350" dirty="0">
+                        <a:rPr lang="en-US" sz="1250" dirty="0">
                           <a:solidFill>
                             <a:srgbClr val="F8FAFC"/>
                           </a:solidFill>
@@ -10000,7 +10000,7 @@
                         </a:rPr>
                         <a:t>sales only</a:t>
                       </a:r>
-                      <a:endParaRPr lang="en-US" sz="1350" dirty="0">
+                      <a:endParaRPr lang="en-US" sz="1250" dirty="0">
                         <a:latin typeface="Calibri" charset="0"/>
                         <a:ea typeface="Calibri" charset="0"/>
                         <a:cs typeface="Calibri" charset="0"/>
@@ -10058,7 +10058,7 @@
                         <a:buNone/>
                       </a:pPr>
                       <a:r>
-                        <a:rPr lang="en-US" sz="1350" dirty="0">
+                        <a:rPr lang="en-US" sz="1250" dirty="0">
                           <a:solidFill>
                             <a:srgbClr val="64748B"/>
                           </a:solidFill>
@@ -10068,7 +10068,7 @@
                         </a:rPr>
                         <a:t>no</a:t>
                       </a:r>
-                      <a:endParaRPr lang="en-US" sz="1350" dirty="0">
+                      <a:endParaRPr lang="en-US" sz="1250" dirty="0">
                         <a:latin typeface="Calibri" charset="0"/>
                         <a:ea typeface="Calibri" charset="0"/>
                         <a:cs typeface="Calibri" charset="0"/>
@@ -10126,7 +10126,7 @@
                         <a:buNone/>
                       </a:pPr>
                       <a:r>
-                        <a:rPr lang="en-US" sz="1350" dirty="0">
+                        <a:rPr lang="en-US" sz="1250" dirty="0">
                           <a:solidFill>
                             <a:srgbClr val="F8FAFC"/>
                           </a:solidFill>
@@ -10136,7 +10136,7 @@
                         </a:rPr>
                         <a:t>yes</a:t>
                       </a:r>
-                      <a:endParaRPr lang="en-US" sz="1350" dirty="0">
+                      <a:endParaRPr lang="en-US" sz="1250" dirty="0">
                         <a:latin typeface="Calibri" charset="0"/>
                         <a:ea typeface="Calibri" charset="0"/>
                         <a:cs typeface="Calibri" charset="0"/>
@@ -10194,7 +10194,7 @@
                         <a:buNone/>
                       </a:pPr>
                       <a:r>
-                        <a:rPr lang="en-US" sz="1350" dirty="0">
+                        <a:rPr lang="en-US" sz="1250" dirty="0">
                           <a:solidFill>
                             <a:srgbClr val="F8FAFC"/>
                           </a:solidFill>
@@ -10204,7 +10204,7 @@
                         </a:rPr>
                         <a:t>cards</a:t>
                       </a:r>
-                      <a:endParaRPr lang="en-US" sz="1350" dirty="0">
+                      <a:endParaRPr lang="en-US" sz="1250" dirty="0">
                         <a:latin typeface="Calibri" charset="0"/>
                         <a:ea typeface="Calibri" charset="0"/>
                         <a:cs typeface="Calibri" charset="0"/>
@@ -10254,7 +10254,7 @@
                   </a:tcPr>
                 </a:tc>
               </a:tr>
-              <a:tr h="585216">
+              <a:tr h="548640">
                 <a:tc>
                   <a:txBody>
                     <a:bodyPr/>
@@ -10264,7 +10264,7 @@
                         <a:buNone/>
                       </a:pPr>
                       <a:r>
-                        <a:rPr lang="en-US" sz="1350" b="1" dirty="0">
+                        <a:rPr lang="en-US" sz="1250" b="1" dirty="0">
                           <a:solidFill>
                             <a:srgbClr val="F8FAFC"/>
                           </a:solidFill>
@@ -10274,7 +10274,7 @@
                         </a:rPr>
                         <a:t>Bulk buying (Spazapp)</a:t>
                       </a:r>
-                      <a:endParaRPr lang="en-US" sz="1350" dirty="0">
+                      <a:endParaRPr lang="en-US" sz="1250" dirty="0">
                         <a:latin typeface="Calibri" charset="0"/>
                         <a:ea typeface="Calibri" charset="0"/>
                         <a:cs typeface="Calibri" charset="0"/>
@@ -10332,7 +10332,7 @@
                         <a:buNone/>
                       </a:pPr>
                       <a:r>
-                        <a:rPr lang="en-US" sz="1350" dirty="0">
+                        <a:rPr lang="en-US" sz="1250" dirty="0">
                           <a:solidFill>
                             <a:srgbClr val="64748B"/>
                           </a:solidFill>
@@ -10342,7 +10342,7 @@
                         </a:rPr>
                         <a:t>no</a:t>
                       </a:r>
-                      <a:endParaRPr lang="en-US" sz="1350" dirty="0">
+                      <a:endParaRPr lang="en-US" sz="1250" dirty="0">
                         <a:latin typeface="Calibri" charset="0"/>
                         <a:ea typeface="Calibri" charset="0"/>
                         <a:cs typeface="Calibri" charset="0"/>
@@ -10400,7 +10400,7 @@
                         <a:buNone/>
                       </a:pPr>
                       <a:r>
-                        <a:rPr lang="en-US" sz="1350" dirty="0">
+                        <a:rPr lang="en-US" sz="1250" dirty="0">
                           <a:solidFill>
                             <a:srgbClr val="F8FAFC"/>
                           </a:solidFill>
@@ -10410,7 +10410,7 @@
                         </a:rPr>
                         <a:t>their range</a:t>
                       </a:r>
-                      <a:endParaRPr lang="en-US" sz="1350" dirty="0">
+                      <a:endParaRPr lang="en-US" sz="1250" dirty="0">
                         <a:latin typeface="Calibri" charset="0"/>
                         <a:ea typeface="Calibri" charset="0"/>
                         <a:cs typeface="Calibri" charset="0"/>
@@ -10468,7 +10468,7 @@
                         <a:buNone/>
                       </a:pPr>
                       <a:r>
-                        <a:rPr lang="en-US" sz="1350" dirty="0">
+                        <a:rPr lang="en-US" sz="1250" dirty="0">
                           <a:solidFill>
                             <a:srgbClr val="F8FAFC"/>
                           </a:solidFill>
@@ -10478,7 +10478,7 @@
                         </a:rPr>
                         <a:t>shops</a:t>
                       </a:r>
-                      <a:endParaRPr lang="en-US" sz="1350" dirty="0">
+                      <a:endParaRPr lang="en-US" sz="1250" dirty="0">
                         <a:latin typeface="Calibri" charset="0"/>
                         <a:ea typeface="Calibri" charset="0"/>
                         <a:cs typeface="Calibri" charset="0"/>
@@ -10536,7 +10536,7 @@
                         <a:buNone/>
                       </a:pPr>
                       <a:r>
-                        <a:rPr lang="en-US" sz="1350" dirty="0">
+                        <a:rPr lang="en-US" sz="1250" dirty="0">
                           <a:solidFill>
                             <a:srgbClr val="F8FAFC"/>
                           </a:solidFill>
@@ -10546,7 +10546,7 @@
                         </a:rPr>
                         <a:t>yes</a:t>
                       </a:r>
-                      <a:endParaRPr lang="en-US" sz="1350" dirty="0">
+                      <a:endParaRPr lang="en-US" sz="1250" dirty="0">
                         <a:latin typeface="Calibri" charset="0"/>
                         <a:ea typeface="Calibri" charset="0"/>
                         <a:cs typeface="Calibri" charset="0"/>
@@ -10596,7 +10596,7 @@
                   </a:tcPr>
                 </a:tc>
               </a:tr>
-              <a:tr h="585216">
+              <a:tr h="548640">
                 <a:tc>
                   <a:txBody>
                     <a:bodyPr/>
@@ -10606,7 +10606,7 @@
                         <a:buNone/>
                       </a:pPr>
                       <a:r>
-                        <a:rPr lang="en-US" sz="1350" b="1" dirty="0">
+                        <a:rPr lang="en-US" sz="1250" b="1" dirty="0">
                           <a:solidFill>
                             <a:srgbClr val="0F172A"/>
                           </a:solidFill>
@@ -10616,7 +10616,7 @@
                         </a:rPr>
                         <a:t>Akayza</a:t>
                       </a:r>
-                      <a:endParaRPr lang="en-US" sz="1350" dirty="0">
+                      <a:endParaRPr lang="en-US" sz="1250" dirty="0">
                         <a:latin typeface="Calibri" charset="0"/>
                         <a:ea typeface="Calibri" charset="0"/>
                         <a:cs typeface="Calibri" charset="0"/>
@@ -10674,7 +10674,7 @@
                         <a:buNone/>
                       </a:pPr>
                       <a:r>
-                        <a:rPr lang="en-US" sz="1350" b="1" dirty="0">
+                        <a:rPr lang="en-US" sz="1250" b="1" dirty="0">
                           <a:solidFill>
                             <a:srgbClr val="0F172A"/>
                           </a:solidFill>
@@ -10682,9 +10682,9 @@
                           <a:ea typeface="Calibri" pitchFamily="34" charset="-122"/>
                           <a:cs typeface="Calibri" pitchFamily="34" charset="-120"/>
                         </a:rPr>
-                        <a:t>yes</a:t>
+                        <a:t>business tools</a:t>
                       </a:r>
-                      <a:endParaRPr lang="en-US" sz="1350" dirty="0">
+                      <a:endParaRPr lang="en-US" sz="1250" dirty="0">
                         <a:latin typeface="Calibri" charset="0"/>
                         <a:ea typeface="Calibri" charset="0"/>
                         <a:cs typeface="Calibri" charset="0"/>
@@ -10742,7 +10742,7 @@
                         <a:buNone/>
                       </a:pPr>
                       <a:r>
-                        <a:rPr lang="en-US" sz="1350" b="1" dirty="0">
+                        <a:rPr lang="en-US" sz="1250" b="1" dirty="0">
                           <a:solidFill>
                             <a:srgbClr val="0F172A"/>
                           </a:solidFill>
@@ -10750,9 +10750,9 @@
                           <a:ea typeface="Calibri" pitchFamily="34" charset="-122"/>
                           <a:cs typeface="Calibri" pitchFamily="34" charset="-120"/>
                         </a:rPr>
-                        <a:t>any supplier</a:t>
+                        <a:t>all your suppliers, one place</a:t>
                       </a:r>
-                      <a:endParaRPr lang="en-US" sz="1350" dirty="0">
+                      <a:endParaRPr lang="en-US" sz="1250" dirty="0">
                         <a:latin typeface="Calibri" charset="0"/>
                         <a:ea typeface="Calibri" charset="0"/>
                         <a:cs typeface="Calibri" charset="0"/>
@@ -10810,7 +10810,7 @@
                         <a:buNone/>
                       </a:pPr>
                       <a:r>
-                        <a:rPr lang="en-US" sz="1350" b="1" dirty="0">
+                        <a:rPr lang="en-US" sz="1250" b="1" dirty="0">
                           <a:solidFill>
                             <a:srgbClr val="0F172A"/>
                           </a:solidFill>
@@ -10820,7 +10820,7 @@
                         </a:rPr>
                         <a:t>yes</a:t>
                       </a:r>
-                      <a:endParaRPr lang="en-US" sz="1350" dirty="0">
+                      <a:endParaRPr lang="en-US" sz="1250" dirty="0">
                         <a:latin typeface="Calibri" charset="0"/>
                         <a:ea typeface="Calibri" charset="0"/>
                         <a:cs typeface="Calibri" charset="0"/>
@@ -10878,7 +10878,7 @@
                         <a:buNone/>
                       </a:pPr>
                       <a:r>
-                        <a:rPr lang="en-US" sz="1350" b="1" dirty="0">
+                        <a:rPr lang="en-US" sz="1250" b="1" dirty="0">
                           <a:solidFill>
                             <a:srgbClr val="0F172A"/>
                           </a:solidFill>
@@ -10886,9 +10886,9 @@
                           <a:ea typeface="Calibri" pitchFamily="34" charset="-122"/>
                           <a:cs typeface="Calibri" pitchFamily="34" charset="-120"/>
                         </a:rPr>
-                        <a:t>yes</a:t>
+                        <a:t>digital, verified</a:t>
                       </a:r>
-                      <a:endParaRPr lang="en-US" sz="1350" dirty="0">
+                      <a:endParaRPr lang="en-US" sz="1250" dirty="0">
                         <a:latin typeface="Calibri" charset="0"/>
                         <a:ea typeface="Calibri" charset="0"/>
                         <a:cs typeface="Calibri" charset="0"/>
@@ -10950,12 +10950,12 @@
         </p:nvSpPr>
         <p:spPr>
           <a:xfrm>
-            <a:off x="548640" y="5394960"/>
-            <a:ext cx="5440680" cy="777240"/>
+            <a:off x="548640" y="5440680"/>
+            <a:ext cx="5440680" cy="822960"/>
           </a:xfrm>
           <a:prstGeom prst="roundRect">
             <a:avLst>
-              <a:gd name="adj" fmla="val 14118"/>
+              <a:gd name="adj" fmla="val 13333"/>
             </a:avLst>
           </a:prstGeom>
           <a:solidFill>
@@ -10977,8 +10977,8 @@
         </p:nvSpPr>
         <p:spPr>
           <a:xfrm>
-            <a:off x="777240" y="5440680"/>
-            <a:ext cx="5029200" cy="685800"/>
+            <a:off x="777240" y="5468112"/>
+            <a:ext cx="5029200" cy="768096"/>
           </a:xfrm>
           <a:prstGeom prst="rect">
             <a:avLst/>
@@ -10994,7 +10994,7 @@
               <a:buNone/>
             </a:pPr>
             <a:r>
-              <a:rPr lang="en-US" sz="1300" b="1" dirty="0">
+              <a:rPr lang="en-US" sz="1250" b="1" dirty="0">
                 <a:solidFill>
                   <a:srgbClr val="FBBF24"/>
                 </a:solidFill>
@@ -11008,7 +11008,7 @@
               <a:buNone/>
             </a:pPr>
             <a:r>
-              <a:rPr lang="en-US" sz="1300" dirty="0">
+              <a:rPr lang="en-US" sz="1250" dirty="0">
                 <a:solidFill>
                   <a:srgbClr val="F8FAFC"/>
                 </a:solidFill>
@@ -11016,9 +11016,9 @@
                 <a:ea typeface="Calibri" pitchFamily="34" charset="-122"/>
                 <a:cs typeface="Calibri" pitchFamily="34" charset="-120"/>
               </a:rPr>
-              <a:t>What a business does today shapes the suppliers it's matched with tomorrow.</a:t>
-            </a:r>
-            <a:endParaRPr lang="en-US" sz="1300" dirty="0"/>
+              <a:t>What a business orders and records today shapes the suppliers it's matched with tomorrow: closer, a better fit, stocking what it buys.</a:t>
+            </a:r>
+            <a:endParaRPr lang="en-US" sz="1250" dirty="0"/>
           </a:p>
         </p:txBody>
       </p:sp>
@@ -11030,12 +11030,12 @@
         </p:nvSpPr>
         <p:spPr>
           <a:xfrm>
-            <a:off x="6172200" y="5394960"/>
-            <a:ext cx="5440680" cy="777240"/>
+            <a:off x="6172200" y="5440680"/>
+            <a:ext cx="5440680" cy="822960"/>
           </a:xfrm>
           <a:prstGeom prst="roundRect">
             <a:avLst>
-              <a:gd name="adj" fmla="val 14118"/>
+              <a:gd name="adj" fmla="val 13333"/>
             </a:avLst>
           </a:prstGeom>
           <a:solidFill>
@@ -11057,8 +11057,8 @@
         </p:nvSpPr>
         <p:spPr>
           <a:xfrm>
-            <a:off x="6400800" y="5440680"/>
-            <a:ext cx="5029200" cy="685800"/>
+            <a:off x="6400800" y="5468112"/>
+            <a:ext cx="5029200" cy="768096"/>
           </a:xfrm>
           <a:prstGeom prst="rect">
             <a:avLst/>
@@ -11074,7 +11074,7 @@
               <a:buNone/>
             </a:pPr>
             <a:r>
-              <a:rPr lang="en-US" sz="1300" b="1" dirty="0">
+              <a:rPr lang="en-US" sz="1250" b="1" dirty="0">
                 <a:solidFill>
                   <a:srgbClr val="FBBF24"/>
                 </a:solidFill>
@@ -11088,7 +11088,7 @@
               <a:buNone/>
             </a:pPr>
             <a:r>
-              <a:rPr lang="en-US" sz="1300" dirty="0">
+              <a:rPr lang="en-US" sz="1250" dirty="0">
                 <a:solidFill>
                   <a:srgbClr val="F8FAFC"/>
                 </a:solidFill>
@@ -11096,9 +11096,9 @@
                 <a:ea typeface="Calibri" pitchFamily="34" charset="-122"/>
                 <a:cs typeface="Calibri" pitchFamily="34" charset="-120"/>
               </a:rPr>
-              <a:t>Provider-verified payments, and a sealed history nobody can quietly change.</a:t>
-            </a:r>
-            <a:endParaRPr lang="en-US" sz="1300" dirty="0"/>
+              <a:t>Digital payments verified by the provider, and a sealed history of stock orders that nobody can quietly change.</a:t>
+            </a:r>
+            <a:endParaRPr lang="en-US" sz="1250" dirty="0"/>
           </a:p>
         </p:txBody>
       </p:sp>

</xml_diff>

<commit_message>
Deck slides 8-10: frontend/backend, digital payments and media, compliance by design (e.g. POPIA), honest proof = digital payments only, no names
Co-Authored-By: Claude Opus 5.5 <noreply@anthropic.com>
Claude-Session: https://claude.ai/code/session_01W9vcEkUR51B1hgQFTnjcUh
</commit_message>
<xml_diff>
--- a/docs/submission/05_final_submission/Akayza_Pitch_TeamPR.pptx
+++ b/docs/submission/05_final_submission/Akayza_Pitch_TeamPR.pptx
@@ -2313,7 +2313,7 @@
           <a:p>
             <a:r>
               <a:rPr lang="en-US" dirty="0"/>
-              <a:t>SAY (only if asked, 15 s): 'Privacy is built in, not added on. We collect only what we need or can verify. Only the owner sees their data. We never touch card numbers or hold money. Nothing personal goes into logs. Nothing is shared without consent. And we're honest about proof: only a provider-verified payment counts as proof.'
+              <a:t>SAY (only if asked, 15 s): 'We comply with the law by design, POPIA for example, not as an afterthought. We collect only what we need or can verify. Only the owner sees their data. We never touch card numbers or hold money. Nothing personal goes into logs. Nothing is shared without consent. And we're honest about proof: only digital payments verified by the provider count as proof.'
 Q&amp;A: security is invisible to the owner (email, password, a code only on a new phone). Breach plan: revoke sessions, rotate keys, tell users and the Information Regulator (POPIA s22). Data export and account closure are built on the server; the buttons come to the app next.</a:t>
             </a:r>
             <a:endParaRPr lang="en-US" dirty="0"/>
@@ -2875,7 +2875,7 @@
                 <a:ea typeface="Calibri" pitchFamily="34" charset="-122"/>
                 <a:cs typeface="Calibri" pitchFamily="34" charset="-120"/>
               </a:rPr>
-              <a:t>Prepared by Team PR: Mandla and Risuna  ·  GKHack26  ·  27 September 2026</a:t>
+              <a:t>Prepared by Team PR  ·  GKHack26  ·  27 September 2026</a:t>
             </a:r>
             <a:endParaRPr lang="en-US" sz="1300" dirty="0"/>
           </a:p>
@@ -3402,7 +3402,7 @@
                 <a:ea typeface="Calibri" pitchFamily="34" charset="-122"/>
                 <a:cs typeface="Calibri" pitchFamily="34" charset="-120"/>
               </a:rPr>
-              <a:t>Making informal and small businesses visible.</a:t>
+              <a:t>Making informal and small businesses visible, and ready for tomorrow.</a:t>
             </a:r>
             <a:endParaRPr lang="en-US" sz="1500" dirty="0"/>
           </a:p>
@@ -3441,7 +3441,7 @@
                 <a:ea typeface="Calibri" pitchFamily="34" charset="-122"/>
                 <a:cs typeface="Calibri" pitchFamily="34" charset="-120"/>
               </a:rPr>
-              <a:t>Team PR  ·  Mandla (lead)  ·  Risuna</a:t>
+              <a:t>Team PR</a:t>
             </a:r>
             <a:endParaRPr lang="en-US" sz="1400" dirty="0"/>
           </a:p>
@@ -11423,7 +11423,7 @@
                 <a:ea typeface="Calibri" pitchFamily="34" charset="-122"/>
                 <a:cs typeface="Calibri" pitchFamily="34" charset="-120"/>
               </a:rPr>
-              <a:t>React Native + Expo (TypeScript). Android first; secure storage for sign-in.</a:t>
+              <a:t>Frontend: React Native + Expo (TypeScript). Android first; secure storage for sign-in.</a:t>
             </a:r>
             <a:endParaRPr lang="en-US" sz="1300" dirty="0"/>
           </a:p>
@@ -11577,7 +11577,7 @@
                 <a:ea typeface="Calibri" pitchFamily="34" charset="-122"/>
                 <a:cs typeface="Calibri" pitchFamily="34" charset="-120"/>
               </a:rPr>
-              <a:t>Python + Flask. Strict input checks, rate limits; the server prices every order.</a:t>
+              <a:t>Backend: Python + Flask. Strict input checks, rate limits; the server prices every order.</a:t>
             </a:r>
             <a:endParaRPr lang="en-US" sz="1300" dirty="0"/>
           </a:p>
@@ -11888,7 +11888,7 @@
               <a:buNone/>
             </a:pPr>
             <a:r>
-              <a:rPr lang="en-US" sz="1450" b="1" dirty="0">
+              <a:rPr lang="en-US" sz="1300" b="1" dirty="0">
                 <a:solidFill>
                   <a:srgbClr val="F8FAFC"/>
                 </a:solidFill>
@@ -11896,9 +11896,9 @@
                 <a:ea typeface="Calibri" pitchFamily="34" charset="-122"/>
                 <a:cs typeface="Calibri" pitchFamily="34" charset="-120"/>
               </a:rPr>
-              <a:t>PayFast</a:t>
-            </a:r>
-            <a:endParaRPr lang="en-US" sz="1450" dirty="0"/>
+              <a:t>Digital payments</a:t>
+            </a:r>
+            <a:endParaRPr lang="en-US" sz="1300" dirty="0"/>
           </a:p>
         </p:txBody>
       </p:sp>
@@ -11935,7 +11935,7 @@
                 <a:ea typeface="Calibri" pitchFamily="34" charset="-122"/>
                 <a:cs typeface="Calibri" pitchFamily="34" charset="-120"/>
               </a:rPr>
-              <a:t>payments, confirmed by 4 checks</a:t>
+              <a:t>PayFast, confirmed by 4 checks</a:t>
             </a:r>
             <a:endParaRPr lang="en-US" sz="1200" dirty="0"/>
           </a:p>
@@ -12042,7 +12042,7 @@
               <a:buNone/>
             </a:pPr>
             <a:r>
-              <a:rPr lang="en-US" sz="1450" b="1" dirty="0">
+              <a:rPr lang="en-US" sz="1300" b="1" dirty="0">
                 <a:solidFill>
                   <a:srgbClr val="F8FAFC"/>
                 </a:solidFill>
@@ -12050,9 +12050,9 @@
                 <a:ea typeface="Calibri" pitchFamily="34" charset="-122"/>
                 <a:cs typeface="Calibri" pitchFamily="34" charset="-120"/>
               </a:rPr>
-              <a:t>Cloudinary</a:t>
-            </a:r>
-            <a:endParaRPr lang="en-US" sz="1450" dirty="0"/>
+              <a:t>Media</a:t>
+            </a:r>
+            <a:endParaRPr lang="en-US" sz="1300" dirty="0"/>
           </a:p>
         </p:txBody>
       </p:sp>
@@ -12089,7 +12089,7 @@
                 <a:ea typeface="Calibri" pitchFamily="34" charset="-122"/>
                 <a:cs typeface="Calibri" pitchFamily="34" charset="-120"/>
               </a:rPr>
-              <a:t>signed photo uploads</a:t>
+              <a:t>Cloudinary: private photos stay private, public ones signed</a:t>
             </a:r>
             <a:endParaRPr lang="en-US" sz="1200" dirty="0"/>
           </a:p>
@@ -12196,7 +12196,7 @@
               <a:buNone/>
             </a:pPr>
             <a:r>
-              <a:rPr lang="en-US" sz="1450" b="1" dirty="0">
+              <a:rPr lang="en-US" sz="1300" b="1" dirty="0">
                 <a:solidFill>
                   <a:srgbClr val="F8FAFC"/>
                 </a:solidFill>
@@ -12206,7 +12206,7 @@
               </a:rPr>
               <a:t>Mapbox</a:t>
             </a:r>
-            <a:endParaRPr lang="en-US" sz="1450" dirty="0"/>
+            <a:endParaRPr lang="en-US" sz="1300" dirty="0"/>
           </a:p>
         </p:txBody>
       </p:sp>
@@ -12350,7 +12350,7 @@
               <a:buNone/>
             </a:pPr>
             <a:r>
-              <a:rPr lang="en-US" sz="1450" b="1" dirty="0">
+              <a:rPr lang="en-US" sz="1300" b="1" dirty="0">
                 <a:solidFill>
                   <a:srgbClr val="F8FAFC"/>
                 </a:solidFill>
@@ -12360,7 +12360,7 @@
               </a:rPr>
               <a:t>Supplier engine</a:t>
             </a:r>
-            <a:endParaRPr lang="en-US" sz="1450" dirty="0"/>
+            <a:endParaRPr lang="en-US" sz="1300" dirty="0"/>
           </a:p>
         </p:txBody>
       </p:sp>
@@ -12882,7 +12882,7 @@
                 <a:ea typeface="Georgia" pitchFamily="34" charset="-122"/>
                 <a:cs typeface="Georgia" pitchFamily="34" charset="-120"/>
               </a:rPr>
-              <a:t>POPIA by design: their data stays theirs</a:t>
+              <a:t>Complying with the law, by design</a:t>
             </a:r>
             <a:endParaRPr lang="en-US" sz="3200" dirty="0"/>
           </a:p>
@@ -12890,7 +12890,46 @@
       </p:sp>
       <p:sp>
         <p:nvSpPr>
-          <p:cNvPr id="4" name="Shape 2"/>
+          <p:cNvPr id="4" name="Text 2"/>
+          <p:cNvSpPr txBox="1"/>
+          <p:nvPr/>
+        </p:nvSpPr>
+        <p:spPr>
+          <a:xfrm>
+            <a:off x="548640" y="1298448"/>
+            <a:ext cx="11064240" cy="365760"/>
+          </a:xfrm>
+          <a:prstGeom prst="rect">
+            <a:avLst/>
+          </a:prstGeom>
+          <a:noFill/>
+          <a:ln/>
+        </p:spPr>
+        <p:txBody>
+          <a:bodyPr wrap="square" lIns="0" tIns="0" rIns="0" bIns="0" rtlCol="0" anchor="t"/>
+          <a:lstStyle/>
+          <a:p>
+            <a:pPr indent="0" marL="0">
+              <a:buNone/>
+            </a:pPr>
+            <a:r>
+              <a:rPr lang="en-US" sz="1500" dirty="0">
+                <a:solidFill>
+                  <a:srgbClr val="A3B3C9"/>
+                </a:solidFill>
+                <a:latin typeface="Calibri" pitchFamily="34" charset="0"/>
+                <a:ea typeface="Calibri" pitchFamily="34" charset="-122"/>
+                <a:cs typeface="Calibri" pitchFamily="34" charset="-120"/>
+              </a:rPr>
+              <a:t>For example POPIA, South Africa's privacy law, and PCI DSS for card payments. Their data stays theirs.</a:t>
+            </a:r>
+            <a:endParaRPr lang="en-US" sz="1500" dirty="0"/>
+          </a:p>
+        </p:txBody>
+      </p:sp>
+      <p:sp>
+        <p:nvSpPr>
+          <p:cNvPr id="5" name="Shape 3"/>
           <p:cNvSpPr/>
           <p:nvPr/>
         </p:nvSpPr>
@@ -12917,7 +12956,7 @@
       </p:sp>
       <p:sp>
         <p:nvSpPr>
-          <p:cNvPr id="5" name="Shape 3"/>
+          <p:cNvPr id="6" name="Shape 4"/>
           <p:cNvSpPr/>
           <p:nvPr/>
         </p:nvSpPr>
@@ -12942,7 +12981,7 @@
       </p:sp>
       <p:pic>
         <p:nvPicPr>
-          <p:cNvPr id="6" name="Image 0" descr="preencoded.png">    </p:cNvPr>
+          <p:cNvPr id="7" name="Image 0" descr="preencoded.png">    </p:cNvPr>
           <p:cNvPicPr>
             <a:picLocks noChangeAspect="1"/>
           </p:cNvPicPr>
@@ -12966,7 +13005,7 @@
       </p:pic>
       <p:sp>
         <p:nvSpPr>
-          <p:cNvPr id="7" name="Text 4"/>
+          <p:cNvPr id="8" name="Text 5"/>
           <p:cNvSpPr txBox="1"/>
           <p:nvPr/>
         </p:nvSpPr>
@@ -13005,7 +13044,7 @@
       </p:sp>
       <p:sp>
         <p:nvSpPr>
-          <p:cNvPr id="8" name="Text 5"/>
+          <p:cNvPr id="9" name="Text 6"/>
           <p:cNvSpPr txBox="1"/>
           <p:nvPr/>
         </p:nvSpPr>
@@ -13044,7 +13083,7 @@
       </p:sp>
       <p:sp>
         <p:nvSpPr>
-          <p:cNvPr id="9" name="Shape 6"/>
+          <p:cNvPr id="10" name="Shape 7"/>
           <p:cNvSpPr/>
           <p:nvPr/>
         </p:nvSpPr>
@@ -13071,7 +13110,7 @@
       </p:sp>
       <p:sp>
         <p:nvSpPr>
-          <p:cNvPr id="10" name="Shape 7"/>
+          <p:cNvPr id="11" name="Shape 8"/>
           <p:cNvSpPr/>
           <p:nvPr/>
         </p:nvSpPr>
@@ -13096,7 +13135,7 @@
       </p:sp>
       <p:pic>
         <p:nvPicPr>
-          <p:cNvPr id="11" name="Image 1" descr="preencoded.png">    </p:cNvPr>
+          <p:cNvPr id="12" name="Image 1" descr="preencoded.png">    </p:cNvPr>
           <p:cNvPicPr>
             <a:picLocks noChangeAspect="1"/>
           </p:cNvPicPr>
@@ -13120,7 +13159,7 @@
       </p:pic>
       <p:sp>
         <p:nvSpPr>
-          <p:cNvPr id="12" name="Text 8"/>
+          <p:cNvPr id="13" name="Text 9"/>
           <p:cNvSpPr txBox="1"/>
           <p:nvPr/>
         </p:nvSpPr>
@@ -13159,7 +13198,7 @@
       </p:sp>
       <p:sp>
         <p:nvSpPr>
-          <p:cNvPr id="13" name="Text 9"/>
+          <p:cNvPr id="14" name="Text 10"/>
           <p:cNvSpPr txBox="1"/>
           <p:nvPr/>
         </p:nvSpPr>
@@ -13198,7 +13237,7 @@
       </p:sp>
       <p:sp>
         <p:nvSpPr>
-          <p:cNvPr id="14" name="Shape 10"/>
+          <p:cNvPr id="15" name="Shape 11"/>
           <p:cNvSpPr/>
           <p:nvPr/>
         </p:nvSpPr>
@@ -13225,7 +13264,7 @@
       </p:sp>
       <p:sp>
         <p:nvSpPr>
-          <p:cNvPr id="15" name="Shape 11"/>
+          <p:cNvPr id="16" name="Shape 12"/>
           <p:cNvSpPr/>
           <p:nvPr/>
         </p:nvSpPr>
@@ -13250,7 +13289,7 @@
       </p:sp>
       <p:pic>
         <p:nvPicPr>
-          <p:cNvPr id="16" name="Image 2" descr="preencoded.png">    </p:cNvPr>
+          <p:cNvPr id="17" name="Image 2" descr="preencoded.png">    </p:cNvPr>
           <p:cNvPicPr>
             <a:picLocks noChangeAspect="1"/>
           </p:cNvPicPr>
@@ -13274,7 +13313,7 @@
       </p:pic>
       <p:sp>
         <p:nvSpPr>
-          <p:cNvPr id="17" name="Text 12"/>
+          <p:cNvPr id="18" name="Text 13"/>
           <p:cNvSpPr txBox="1"/>
           <p:nvPr/>
         </p:nvSpPr>
@@ -13313,7 +13352,7 @@
       </p:sp>
       <p:sp>
         <p:nvSpPr>
-          <p:cNvPr id="18" name="Text 13"/>
+          <p:cNvPr id="19" name="Text 14"/>
           <p:cNvSpPr txBox="1"/>
           <p:nvPr/>
         </p:nvSpPr>
@@ -13352,7 +13391,7 @@
       </p:sp>
       <p:sp>
         <p:nvSpPr>
-          <p:cNvPr id="19" name="Shape 14"/>
+          <p:cNvPr id="20" name="Shape 15"/>
           <p:cNvSpPr/>
           <p:nvPr/>
         </p:nvSpPr>
@@ -13379,7 +13418,7 @@
       </p:sp>
       <p:sp>
         <p:nvSpPr>
-          <p:cNvPr id="20" name="Shape 15"/>
+          <p:cNvPr id="21" name="Shape 16"/>
           <p:cNvSpPr/>
           <p:nvPr/>
         </p:nvSpPr>
@@ -13404,7 +13443,7 @@
       </p:sp>
       <p:pic>
         <p:nvPicPr>
-          <p:cNvPr id="21" name="Image 3" descr="preencoded.png">    </p:cNvPr>
+          <p:cNvPr id="22" name="Image 3" descr="preencoded.png">    </p:cNvPr>
           <p:cNvPicPr>
             <a:picLocks noChangeAspect="1"/>
           </p:cNvPicPr>
@@ -13428,7 +13467,7 @@
       </p:pic>
       <p:sp>
         <p:nvSpPr>
-          <p:cNvPr id="22" name="Text 16"/>
+          <p:cNvPr id="23" name="Text 17"/>
           <p:cNvSpPr txBox="1"/>
           <p:nvPr/>
         </p:nvSpPr>
@@ -13467,7 +13506,7 @@
       </p:sp>
       <p:sp>
         <p:nvSpPr>
-          <p:cNvPr id="23" name="Text 17"/>
+          <p:cNvPr id="24" name="Text 18"/>
           <p:cNvSpPr txBox="1"/>
           <p:nvPr/>
         </p:nvSpPr>
@@ -13506,7 +13545,7 @@
       </p:sp>
       <p:sp>
         <p:nvSpPr>
-          <p:cNvPr id="24" name="Shape 18"/>
+          <p:cNvPr id="25" name="Shape 19"/>
           <p:cNvSpPr/>
           <p:nvPr/>
         </p:nvSpPr>
@@ -13533,7 +13572,7 @@
       </p:sp>
       <p:sp>
         <p:nvSpPr>
-          <p:cNvPr id="25" name="Shape 19"/>
+          <p:cNvPr id="26" name="Shape 20"/>
           <p:cNvSpPr/>
           <p:nvPr/>
         </p:nvSpPr>
@@ -13558,7 +13597,7 @@
       </p:sp>
       <p:pic>
         <p:nvPicPr>
-          <p:cNvPr id="26" name="Image 4" descr="preencoded.png">    </p:cNvPr>
+          <p:cNvPr id="27" name="Image 4" descr="preencoded.png">    </p:cNvPr>
           <p:cNvPicPr>
             <a:picLocks noChangeAspect="1"/>
           </p:cNvPicPr>
@@ -13582,7 +13621,7 @@
       </p:pic>
       <p:sp>
         <p:nvSpPr>
-          <p:cNvPr id="27" name="Text 20"/>
+          <p:cNvPr id="28" name="Text 21"/>
           <p:cNvSpPr txBox="1"/>
           <p:nvPr/>
         </p:nvSpPr>
@@ -13621,7 +13660,7 @@
       </p:sp>
       <p:sp>
         <p:nvSpPr>
-          <p:cNvPr id="28" name="Text 21"/>
+          <p:cNvPr id="29" name="Text 22"/>
           <p:cNvSpPr txBox="1"/>
           <p:nvPr/>
         </p:nvSpPr>
@@ -13660,7 +13699,7 @@
       </p:sp>
       <p:sp>
         <p:nvSpPr>
-          <p:cNvPr id="29" name="Shape 22"/>
+          <p:cNvPr id="30" name="Shape 23"/>
           <p:cNvSpPr/>
           <p:nvPr/>
         </p:nvSpPr>
@@ -13687,7 +13726,7 @@
       </p:sp>
       <p:sp>
         <p:nvSpPr>
-          <p:cNvPr id="30" name="Shape 23"/>
+          <p:cNvPr id="31" name="Shape 24"/>
           <p:cNvSpPr/>
           <p:nvPr/>
         </p:nvSpPr>
@@ -13712,7 +13751,7 @@
       </p:sp>
       <p:pic>
         <p:nvPicPr>
-          <p:cNvPr id="31" name="Image 5" descr="preencoded.png">    </p:cNvPr>
+          <p:cNvPr id="32" name="Image 5" descr="preencoded.png">    </p:cNvPr>
           <p:cNvPicPr>
             <a:picLocks noChangeAspect="1"/>
           </p:cNvPicPr>
@@ -13736,7 +13775,7 @@
       </p:pic>
       <p:sp>
         <p:nvSpPr>
-          <p:cNvPr id="32" name="Text 24"/>
+          <p:cNvPr id="33" name="Text 25"/>
           <p:cNvSpPr txBox="1"/>
           <p:nvPr/>
         </p:nvSpPr>
@@ -13775,7 +13814,7 @@
       </p:sp>
       <p:sp>
         <p:nvSpPr>
-          <p:cNvPr id="33" name="Text 25"/>
+          <p:cNvPr id="34" name="Text 26"/>
           <p:cNvSpPr txBox="1"/>
           <p:nvPr/>
         </p:nvSpPr>
@@ -13814,7 +13853,7 @@
       </p:sp>
       <p:sp>
         <p:nvSpPr>
-          <p:cNvPr id="34" name="Shape 26"/>
+          <p:cNvPr id="35" name="Shape 27"/>
           <p:cNvSpPr/>
           <p:nvPr/>
         </p:nvSpPr>
@@ -13841,7 +13880,7 @@
       </p:sp>
       <p:sp>
         <p:nvSpPr>
-          <p:cNvPr id="35" name="Text 27"/>
+          <p:cNvPr id="36" name="Text 28"/>
           <p:cNvSpPr txBox="1"/>
           <p:nvPr/>
         </p:nvSpPr>
@@ -13886,7 +13925,7 @@
                 <a:ea typeface="Calibri" pitchFamily="34" charset="-122"/>
                 <a:cs typeface="Calibri" pitchFamily="34" charset="-120"/>
               </a:rPr>
-              <a:t>Only a payment verified by the provider is proof. Cash is at most 'confirmed by both'; tool records are the owner's own. Never added together.</a:t>
+              <a:t>Only digital payments verified by the payment provider count as proof. Everything else is the owner's own record, and is never added to it.</a:t>
             </a:r>
             <a:endParaRPr lang="en-US" sz="1300" dirty="0"/>
           </a:p>
@@ -13894,7 +13933,7 @@
       </p:sp>
       <p:pic>
         <p:nvPicPr>
-          <p:cNvPr id="36" name="Image 6" descr="preencoded.png">    </p:cNvPr>
+          <p:cNvPr id="37" name="Image 6" descr="preencoded.png">    </p:cNvPr>
           <p:cNvPicPr>
             <a:picLocks noChangeAspect="1"/>
           </p:cNvPicPr>
@@ -13918,7 +13957,7 @@
       </p:pic>
       <p:sp>
         <p:nvSpPr>
-          <p:cNvPr id="37" name="Text 28"/>
+          <p:cNvPr id="38" name="Text 29"/>
           <p:cNvSpPr txBox="1"/>
           <p:nvPr/>
         </p:nvSpPr>

</xml_diff>

<commit_message>
Deck: suppliers pay a subscription or contract plus a commission on every order; last slide 'Prepared by Team PR'
Co-Authored-By: Claude Opus 5.5 <noreply@anthropic.com>
Claude-Session: https://claude.ai/code/session_01W9vcEkUR51B1hgQFTnjcUh
</commit_message>
<xml_diff>
--- a/docs/submission/05_final_submission/Akayza_Pitch_TeamPR.pptx
+++ b/docs/submission/05_final_submission/Akayza_Pitch_TeamPR.pptx
@@ -1775,7 +1775,7 @@
           <a:p>
             <a:r>
               <a:rPr lang="en-US" dirty="0"/>
-              <a:t>SAY (25 s): 'That's where Akayza comes in. One free app that makes the business visible, and ready for tomorrow. It works the way they already operate, cash or digital. Every digital stock order becomes a record the owner holds, and over time a strong trading history. Today, the business tools take the stress away. This week, they buy better from their own suppliers and pay safely. Tomorrow, that history is their first step to finance. Businesses never pay. Suppliers are our customers: they pay a monthly fee because we bring them more orders, paid up front. And next, banks and lenders, as partners, only with the owner's consent.'
+              <a:t>SAY (25 s): 'That's where Akayza comes in. One free app that makes the business visible, and ready for tomorrow. It works the way they already operate, cash or digital. Every digital stock order becomes a record the owner holds, and over time a strong trading history. Today, the business tools take the stress away. This week, they buy better from their own suppliers and pay safely. Tomorrow, that history is their first step to finance. Businesses never pay. Suppliers are our customers: they pay a monthly subscription or contract, plus a commission on every order, because we bring them more orders. And next, banks and lenders, as partners, only with the owner's consent.'
 HONEST LIMIT (say it before a judge does): 'We only call digital payments proof, because the payment provider confirms the money moved. Cash and what an owner writes in the tools is their own record. We never add them together.'
 We don't lend or offer credit ourselves; banks and lenders are future partners.</a:t>
             </a:r>
@@ -3441,7 +3441,7 @@
                 <a:ea typeface="Calibri" pitchFamily="34" charset="-122"/>
                 <a:cs typeface="Calibri" pitchFamily="34" charset="-120"/>
               </a:rPr>
-              <a:t>Team PR</a:t>
+              <a:t>Prepared by Team PR</a:t>
             </a:r>
             <a:endParaRPr lang="en-US" sz="1400" dirty="0"/>
           </a:p>
@@ -5240,7 +5240,7 @@
                 <a:ea typeface="Calibri" pitchFamily="34" charset="-122"/>
                 <a:cs typeface="Calibri" pitchFamily="34" charset="-120"/>
               </a:rPr>
-              <a:t>Pay a monthly fee for more orders from the businesses they already serve, paid up front, with no cash lost on the road.</a:t>
+              <a:t>Pay a monthly subscription or contract, plus a commission on every order: more orders from the businesses they already serve.</a:t>
             </a:r>
             <a:endParaRPr lang="en-US" sz="1200" dirty="0"/>
           </a:p>

</xml_diff>

<commit_message>
Deck slide 10 opens the demo video on Drive; a start card for the video that names every kind of business
Co-Authored-By: Claude Opus 5.5 <noreply@anthropic.com>
Claude-Session: https://claude.ai/code/session_01W9vcEkUR51B1hgQFTnjcUh
</commit_message>
<xml_diff>
--- a/docs/submission/05_final_submission/Akayza_Pitch_TeamPR.pptx
+++ b/docs/submission/05_final_submission/Akayza_Pitch_TeamPR.pptx
@@ -1595,7 +1595,7 @@
             <a:r>
               <a:rPr lang="en-US" dirty="0"/>
               <a:t>DEMO (50 s): play the video, or do it live. Let it speak; don't narrate every tap. Before going on: phone charged, backend + ngrok running.
-Replace '[paste link here]' with the real link, and link the play button too (Insert &gt; Link).
+The card and 'Watch the demo' open the video on Google Drive. In the room, open it in the browser before you start, so it's one click away.
 CLOSE (10 s), look at the panel, not the screen: 'R900 billion is moving, and nobody can see it. Akayza makes it visible, and suppliers pay for it. It's built, it works, and R300,000 puts it in real businesses. Are you buying?' Then stop talking.</a:t>
             </a:r>
             <a:endParaRPr lang="en-US" dirty="0"/>
@@ -3070,7 +3070,7 @@
         </p:nvSpPr>
         <p:spPr>
           <a:xfrm>
-            <a:off x="2926080" y="1828800"/>
+            <a:off x="2926080" y="1417320"/>
             <a:ext cx="1280160" cy="1280160"/>
           </a:xfrm>
           <a:prstGeom prst="ellipse">
@@ -3103,7 +3103,7 @@
         </p:blipFill>
         <p:spPr>
           <a:xfrm>
-            <a:off x="3233318" y="2136038"/>
+            <a:off x="3233318" y="1724558"/>
             <a:ext cx="665683" cy="665683"/>
           </a:xfrm>
           <a:prstGeom prst="rect">
@@ -3113,14 +3113,45 @@
       </p:pic>
       <p:sp>
         <p:nvSpPr>
-          <p:cNvPr id="6" name="Text 3"/>
-          <p:cNvSpPr txBox="1"/>
-          <p:nvPr/>
-        </p:nvSpPr>
-        <p:spPr>
-          <a:xfrm>
-            <a:off x="731520" y="3429000"/>
-            <a:ext cx="5669280" cy="411480"/>
+          <p:cNvPr id="6" name="Shape 3">
+            <a:hlinkClick r:id="rId2" tooltip="Watch the demo"/>
+          </p:cNvPr>
+          <p:cNvSpPr/>
+          <p:nvPr/>
+        </p:nvSpPr>
+        <p:spPr>
+          <a:xfrm>
+            <a:off x="548640" y="914400"/>
+            <a:ext cx="6035040" cy="4206240"/>
+          </a:xfrm>
+          <a:prstGeom prst="rect">
+            <a:avLst/>
+          </a:prstGeom>
+          <a:solidFill>
+            <a:srgbClr val="0F172A">
+              <a:alpha val="0"/>
+            </a:srgbClr>
+          </a:solidFill>
+          <a:ln w="12700">
+            <a:solidFill>
+              <a:srgbClr val="0F172A">
+                <a:alpha val="0"/>
+              </a:srgbClr>
+            </a:solidFill>
+            <a:prstDash val="solid"/>
+          </a:ln>
+        </p:spPr>
+      </p:sp>
+      <p:sp>
+        <p:nvSpPr>
+          <p:cNvPr id="7" name="Text 4"/>
+          <p:cNvSpPr txBox="1"/>
+          <p:nvPr/>
+        </p:nvSpPr>
+        <p:spPr>
+          <a:xfrm>
+            <a:off x="822960" y="2926080"/>
+            <a:ext cx="5486400" cy="685800"/>
           </a:xfrm>
           <a:prstGeom prst="rect">
             <a:avLst/>
@@ -3144,7 +3175,7 @@
                 <a:ea typeface="Calibri" pitchFamily="34" charset="-122"/>
                 <a:cs typeface="Calibri" pitchFamily="34" charset="-120"/>
               </a:rPr>
-              <a:t>90-second demo, on a real phone, against our real system</a:t>
+              <a:t>Meet Sipho and Thabo: 81 seconds, on a real phone, against our real system</a:t>
             </a:r>
             <a:endParaRPr lang="en-US" sz="1500" dirty="0"/>
           </a:p>
@@ -3152,14 +3183,14 @@
       </p:sp>
       <p:sp>
         <p:nvSpPr>
-          <p:cNvPr id="7" name="Text 4"/>
-          <p:cNvSpPr txBox="1"/>
-          <p:nvPr/>
-        </p:nvSpPr>
-        <p:spPr>
-          <a:xfrm>
-            <a:off x="731520" y="3931920"/>
-            <a:ext cx="5669280" cy="365760"/>
+          <p:cNvPr id="8" name="Text 5"/>
+          <p:cNvSpPr txBox="1"/>
+          <p:nvPr/>
+        </p:nvSpPr>
+        <p:spPr>
+          <a:xfrm>
+            <a:off x="822960" y="3657600"/>
+            <a:ext cx="5486400" cy="365760"/>
           </a:xfrm>
           <a:prstGeom prst="rect">
             <a:avLst/>
@@ -3175,30 +3206,37 @@
               <a:buNone/>
             </a:pPr>
             <a:r>
-              <a:rPr lang="en-US" sz="1400" dirty="0">
+              <a:rPr lang="en-US" sz="1600" b="1" u="sng" dirty="0">
                 <a:solidFill>
                   <a:srgbClr val="FBBF24"/>
                 </a:solidFill>
                 <a:latin typeface="Calibri" pitchFamily="34" charset="0"/>
                 <a:ea typeface="Calibri" pitchFamily="34" charset="-122"/>
                 <a:cs typeface="Calibri" pitchFamily="34" charset="-120"/>
-              </a:rPr>
-              <a:t>Video: [paste link here]</a:t>
-            </a:r>
-            <a:endParaRPr lang="en-US" sz="1400" dirty="0"/>
-          </a:p>
-        </p:txBody>
-      </p:sp>
-      <p:sp>
-        <p:nvSpPr>
-          <p:cNvPr id="8" name="Text 5"/>
-          <p:cNvSpPr txBox="1"/>
-          <p:nvPr/>
-        </p:nvSpPr>
-        <p:spPr>
-          <a:xfrm>
-            <a:off x="731520" y="4480560"/>
-            <a:ext cx="5669280" cy="457200"/>
+                <a:hlinkClick r:id="rId3" invalidUrl="" action="" tgtFrame="" tooltip="Watch the demo" history="1" highlightClick="0" endSnd="0">
+                  <a:extLst>
+                    <a:ext uri="{A12FA001-AC4F-418D-AE19-62706E023703}">
+                      <ahyp:hlinkClr xmlns:ahyp="http://schemas.microsoft.com/office/drawing/2018/hyperlinkcolor" val="tx"/>
+                    </a:ext>
+                  </a:extLst>
+                </a:hlinkClick>
+              </a:rPr>
+              <a:t>Watch the demo</a:t>
+            </a:r>
+            <a:endParaRPr lang="en-US" sz="1600" dirty="0"/>
+          </a:p>
+        </p:txBody>
+      </p:sp>
+      <p:sp>
+        <p:nvSpPr>
+          <p:cNvPr id="9" name="Text 6"/>
+          <p:cNvSpPr txBox="1"/>
+          <p:nvPr/>
+        </p:nvSpPr>
+        <p:spPr>
+          <a:xfrm>
+            <a:off x="822960" y="4160520"/>
+            <a:ext cx="5486400" cy="731520"/>
           </a:xfrm>
           <a:prstGeom prst="rect">
             <a:avLst/>
@@ -3222,22 +3260,68 @@
                 <a:ea typeface="Calibri" pitchFamily="34" charset="-122"/>
                 <a:cs typeface="Calibri" pitchFamily="34" charset="-120"/>
               </a:rPr>
-              <a:t>Home at a glance  ·  suppliers matched  ·  paid and confirmed  ·  a sealed record</a:t>
+              <a:t>A kota shop orders from suppliers who deliver, pays in the app, confirmed by the provider  ·  a builder's job in stages</a:t>
             </a:r>
             <a:endParaRPr lang="en-US" sz="1200" dirty="0"/>
+          </a:p>
+        </p:txBody>
+      </p:sp>
+      <p:sp>
+        <p:nvSpPr>
+          <p:cNvPr id="10" name="Text 7"/>
+          <p:cNvSpPr txBox="1"/>
+          <p:nvPr/>
+        </p:nvSpPr>
+        <p:spPr>
+          <a:xfrm>
+            <a:off x="548640" y="5257800"/>
+            <a:ext cx="6035040" cy="274320"/>
+          </a:xfrm>
+          <a:prstGeom prst="rect">
+            <a:avLst/>
+          </a:prstGeom>
+          <a:noFill/>
+          <a:ln/>
+        </p:spPr>
+        <p:txBody>
+          <a:bodyPr wrap="square" lIns="0" tIns="0" rIns="0" bIns="0" rtlCol="0" anchor="t"/>
+          <a:lstStyle/>
+          <a:p>
+            <a:pPr algn="ctr" indent="0" marL="0">
+              <a:buNone/>
+            </a:pPr>
+            <a:r>
+              <a:rPr lang="en-US" sz="900" u="sng" dirty="0">
+                <a:solidFill>
+                  <a:srgbClr val="64748B"/>
+                </a:solidFill>
+                <a:latin typeface="Calibri" pitchFamily="34" charset="0"/>
+                <a:ea typeface="Calibri" pitchFamily="34" charset="-122"/>
+                <a:cs typeface="Calibri" pitchFamily="34" charset="-120"/>
+                <a:hlinkClick r:id="rId4" invalidUrl="" action="" tgtFrame="" tooltip="" history="1" highlightClick="0" endSnd="0">
+                  <a:extLst>
+                    <a:ext uri="{A12FA001-AC4F-418D-AE19-62706E023703}">
+                      <ahyp:hlinkClr xmlns:ahyp="http://schemas.microsoft.com/office/drawing/2018/hyperlinkcolor" val="tx"/>
+                    </a:ext>
+                  </a:extLst>
+                </a:hlinkClick>
+              </a:rPr>
+              <a:t>https://drive.google.com/file/d/1yYQfVBEG-dnn-hxgRRtD5xDVw8vZV8Es/view</a:t>
+            </a:r>
+            <a:endParaRPr lang="en-US" sz="900" dirty="0"/>
           </a:p>
         </p:txBody>
       </p:sp>
       <p:pic>
         <p:nvPicPr>
-          <p:cNvPr id="9" name="Image 1" descr="preencoded.png">    </p:cNvPr>
+          <p:cNvPr id="11" name="Image 1" descr="preencoded.png">    </p:cNvPr>
           <p:cNvPicPr>
             <a:picLocks noChangeAspect="1"/>
           </p:cNvPicPr>
           <p:nvPr/>
         </p:nvPicPr>
         <p:blipFill>
-          <a:blip r:embed="rId2"/>
+          <a:blip r:embed="rId5"/>
           <a:stretch>
             <a:fillRect/>
           </a:stretch>
@@ -3254,7 +3338,7 @@
       </p:pic>
       <p:sp>
         <p:nvSpPr>
-          <p:cNvPr id="10" name="Text 6"/>
+          <p:cNvPr id="12" name="Text 8"/>
           <p:cNvSpPr txBox="1"/>
           <p:nvPr/>
         </p:nvSpPr>
@@ -3293,7 +3377,7 @@
       </p:sp>
       <p:sp>
         <p:nvSpPr>
-          <p:cNvPr id="11" name="Text 7"/>
+          <p:cNvPr id="13" name="Text 9"/>
           <p:cNvSpPr txBox="1"/>
           <p:nvPr/>
         </p:nvSpPr>
@@ -3332,7 +3416,7 @@
       </p:sp>
       <p:sp>
         <p:nvSpPr>
-          <p:cNvPr id="12" name="Text 8"/>
+          <p:cNvPr id="14" name="Text 10"/>
           <p:cNvSpPr txBox="1"/>
           <p:nvPr/>
         </p:nvSpPr>
@@ -3371,7 +3455,7 @@
       </p:sp>
       <p:sp>
         <p:nvSpPr>
-          <p:cNvPr id="13" name="Text 9"/>
+          <p:cNvPr id="15" name="Text 11"/>
           <p:cNvSpPr txBox="1"/>
           <p:nvPr/>
         </p:nvSpPr>
@@ -3410,7 +3494,7 @@
       </p:sp>
       <p:sp>
         <p:nvSpPr>
-          <p:cNvPr id="14" name="Text 10"/>
+          <p:cNvPr id="16" name="Text 12"/>
           <p:cNvSpPr txBox="1"/>
           <p:nvPr/>
         </p:nvSpPr>
@@ -3449,14 +3533,14 @@
       </p:sp>
       <p:pic>
         <p:nvPicPr>
-          <p:cNvPr id="15" name="Image 2" descr="preencoded.png">    </p:cNvPr>
+          <p:cNvPr id="17" name="Image 2" descr="preencoded.png">    </p:cNvPr>
           <p:cNvPicPr>
             <a:picLocks noChangeAspect="1"/>
           </p:cNvPicPr>
           <p:nvPr/>
         </p:nvPicPr>
         <p:blipFill>
-          <a:blip r:embed="rId3"/>
+          <a:blip r:embed="rId6"/>
           <a:stretch>
             <a:fillRect/>
           </a:stretch>
@@ -3473,7 +3557,7 @@
       </p:pic>
       <p:sp>
         <p:nvSpPr>
-          <p:cNvPr id="16" name="Text 11"/>
+          <p:cNvPr id="18" name="Text 13"/>
           <p:cNvSpPr txBox="1"/>
           <p:nvPr/>
         </p:nvSpPr>

</xml_diff>

<commit_message>
Deck slide 10: the 49-second demo plays inside the deck (Risuna's room cut), full 81-second video linked on Drive
Co-Authored-By: Claude Opus 5.5 <noreply@anthropic.com>
Claude-Session: https://claude.ai/code/session_01W9vcEkUR51B1hgQFTnjcUh
</commit_message>
<xml_diff>
--- a/docs/submission/05_final_submission/Akayza_Pitch_TeamPR.pptx
+++ b/docs/submission/05_final_submission/Akayza_Pitch_TeamPR.pptx
@@ -1594,8 +1594,9 @@
           <a:p>
             <a:r>
               <a:rPr lang="en-US" dirty="0"/>
-              <a:t>DEMO (50 s): play the video, or do it live. Let it speak; don't narrate every tap. Before going on: phone charged, backend + ngrok running.
-The card and 'Watch the demo' open the video on Google Drive. In the room, open it in the browser before you start, so it's one click away.
+              <a:t>DEMO (49 s): click the video to play it (it's inside the deck; no Wi-Fi needed). It's silent, so speak over it, one line per scene:
+'Any kasi business. Sipho runs a kota shop: he picks Food seller, and drops a pin where he trades. Akayza shows him suppliers who deliver to him. He orders bread from a bakery that delivers, and pays on PayFast's own page: confirmed by the payment provider. Every kota he sells goes in his order book, and his record marks the provider-confirmed payments. Now Thabo, a builder: every stage photographed in the app, and his client confirms it. That's his track record.'
+To make it start by itself: in PowerPoint, select the video &gt; Playback &gt; Start: Automatically.
 CLOSE (10 s), look at the panel, not the screen: 'R900 billion is moving, and nobody can see it. Akayza makes it visible, and suppliers pay for it. It's built, it works, and R300,000 puts it in real businesses. Are you buying?' Then stop talking.</a:t>
             </a:r>
             <a:endParaRPr lang="en-US" dirty="0"/>
@@ -3043,12 +3044,12 @@
         </p:nvSpPr>
         <p:spPr>
           <a:xfrm>
-            <a:off x="548640" y="914400"/>
-            <a:ext cx="6035040" cy="4206240"/>
+            <a:off x="475488" y="841248"/>
+            <a:ext cx="6364224" cy="3653028"/>
           </a:xfrm>
           <a:prstGeom prst="roundRect">
             <a:avLst>
-              <a:gd name="adj" fmla="val 2609"/>
+              <a:gd name="adj" fmla="val 3004"/>
             </a:avLst>
           </a:prstGeom>
           <a:solidFill>
@@ -3062,49 +3063,33 @@
           </a:ln>
         </p:spPr>
       </p:sp>
-      <p:sp>
-        <p:nvSpPr>
-          <p:cNvPr id="4" name="Shape 2"/>
-          <p:cNvSpPr/>
-          <p:nvPr/>
-        </p:nvSpPr>
-        <p:spPr>
-          <a:xfrm>
-            <a:off x="2926080" y="1417320"/>
-            <a:ext cx="1280160" cy="1280160"/>
-          </a:xfrm>
-          <a:prstGeom prst="ellipse">
-            <a:avLst/>
-          </a:prstGeom>
-          <a:solidFill>
-            <a:srgbClr val="1E2B45"/>
-          </a:solidFill>
-          <a:ln w="19050">
-            <a:solidFill>
-              <a:srgbClr val="FBBF24"/>
-            </a:solidFill>
-            <a:prstDash val="solid"/>
-          </a:ln>
-        </p:spPr>
-      </p:sp>
       <p:pic>
         <p:nvPicPr>
-          <p:cNvPr id="5" name="Image 0" descr="preencoded.png">    </p:cNvPr>
+          <p:cNvPr id="3" name="Demo video">
+            <a:hlinkClick r:id="" action="ppaction://media"/>
+          </p:cNvPr>
           <p:cNvPicPr>
             <a:picLocks noChangeAspect="1"/>
           </p:cNvPicPr>
-          <p:nvPr/>
+          <p:nvPr>
+            <a:videoFile r:link="rId1"/>
+            <p:extLst>
+              <p:ext uri="{DAA4B4D4-6D71-4841-9C94-3DE7FCFB9230}">
+                <p14:media xmlns:p14="http://schemas.microsoft.com/office/powerpoint/2010/main" r:embed="rId2"/>
+              </p:ext>
+            </p:extLst>
+          </p:nvPr>
         </p:nvPicPr>
         <p:blipFill>
-          <a:blip r:embed="rId1"/>
+          <a:blip r:embed="rId3"/>
           <a:stretch>
             <a:fillRect/>
           </a:stretch>
         </p:blipFill>
         <p:spPr>
           <a:xfrm>
-            <a:off x="3233318" y="1724558"/>
-            <a:ext cx="665683" cy="665683"/>
+            <a:off x="548640" y="914400"/>
+            <a:ext cx="6217920" cy="3497580"/>
           </a:xfrm>
           <a:prstGeom prst="rect">
             <a:avLst/>
@@ -3113,45 +3098,14 @@
       </p:pic>
       <p:sp>
         <p:nvSpPr>
-          <p:cNvPr id="6" name="Shape 3">
-            <a:hlinkClick r:id="rId2" tooltip="Watch the demo"/>
-          </p:cNvPr>
-          <p:cNvSpPr/>
-          <p:nvPr/>
-        </p:nvSpPr>
-        <p:spPr>
-          <a:xfrm>
-            <a:off x="548640" y="914400"/>
-            <a:ext cx="6035040" cy="4206240"/>
-          </a:xfrm>
-          <a:prstGeom prst="rect">
-            <a:avLst/>
-          </a:prstGeom>
-          <a:solidFill>
-            <a:srgbClr val="0F172A">
-              <a:alpha val="0"/>
-            </a:srgbClr>
-          </a:solidFill>
-          <a:ln w="12700">
-            <a:solidFill>
-              <a:srgbClr val="0F172A">
-                <a:alpha val="0"/>
-              </a:srgbClr>
-            </a:solidFill>
-            <a:prstDash val="solid"/>
-          </a:ln>
-        </p:spPr>
-      </p:sp>
-      <p:sp>
-        <p:nvSpPr>
-          <p:cNvPr id="7" name="Text 4"/>
-          <p:cNvSpPr txBox="1"/>
-          <p:nvPr/>
-        </p:nvSpPr>
-        <p:spPr>
-          <a:xfrm>
-            <a:off x="822960" y="2926080"/>
-            <a:ext cx="5486400" cy="685800"/>
+          <p:cNvPr id="5" name="Text 2"/>
+          <p:cNvSpPr txBox="1"/>
+          <p:nvPr/>
+        </p:nvSpPr>
+        <p:spPr>
+          <a:xfrm>
+            <a:off x="548640" y="4617720"/>
+            <a:ext cx="6217920" cy="365760"/>
           </a:xfrm>
           <a:prstGeom prst="rect">
             <a:avLst/>
@@ -3167,7 +3121,7 @@
               <a:buNone/>
             </a:pPr>
             <a:r>
-              <a:rPr lang="en-US" sz="1500" b="1" dirty="0">
+              <a:rPr lang="en-US" sz="1400" b="1" dirty="0">
                 <a:solidFill>
                   <a:srgbClr val="F8FAFC"/>
                 </a:solidFill>
@@ -3175,22 +3129,22 @@
                 <a:ea typeface="Calibri" pitchFamily="34" charset="-122"/>
                 <a:cs typeface="Calibri" pitchFamily="34" charset="-120"/>
               </a:rPr>
-              <a:t>Meet Sipho and Thabo: 81 seconds, on a real phone, against our real system</a:t>
-            </a:r>
-            <a:endParaRPr lang="en-US" sz="1500" dirty="0"/>
-          </a:p>
-        </p:txBody>
-      </p:sp>
-      <p:sp>
-        <p:nvSpPr>
-          <p:cNvPr id="8" name="Text 5"/>
-          <p:cNvSpPr txBox="1"/>
-          <p:nvPr/>
-        </p:nvSpPr>
-        <p:spPr>
-          <a:xfrm>
-            <a:off x="822960" y="3657600"/>
-            <a:ext cx="5486400" cy="365760"/>
+              <a:t>Meet Sipho and Thabo, on a real phone</a:t>
+            </a:r>
+            <a:endParaRPr lang="en-US" sz="1400" dirty="0"/>
+          </a:p>
+        </p:txBody>
+      </p:sp>
+      <p:sp>
+        <p:nvSpPr>
+          <p:cNvPr id="6" name="Text 3"/>
+          <p:cNvSpPr txBox="1"/>
+          <p:nvPr/>
+        </p:nvSpPr>
+        <p:spPr>
+          <a:xfrm>
+            <a:off x="548640" y="5029200"/>
+            <a:ext cx="6217920" cy="320040"/>
           </a:xfrm>
           <a:prstGeom prst="rect">
             <a:avLst/>
@@ -3206,14 +3160,14 @@
               <a:buNone/>
             </a:pPr>
             <a:r>
-              <a:rPr lang="en-US" sz="1600" b="1" u="sng" dirty="0">
+              <a:rPr lang="en-US" sz="1300" b="1" u="sng" dirty="0">
                 <a:solidFill>
                   <a:srgbClr val="FBBF24"/>
                 </a:solidFill>
                 <a:latin typeface="Calibri" pitchFamily="34" charset="0"/>
                 <a:ea typeface="Calibri" pitchFamily="34" charset="-122"/>
                 <a:cs typeface="Calibri" pitchFamily="34" charset="-120"/>
-                <a:hlinkClick r:id="rId3" invalidUrl="" action="" tgtFrame="" tooltip="Watch the demo" history="1" highlightClick="0" endSnd="0">
+                <a:hlinkClick r:id="rId4" invalidUrl="" action="" tgtFrame="" tooltip="Watch the full demo" history="1" highlightClick="0" endSnd="0">
                   <a:extLst>
                     <a:ext uri="{A12FA001-AC4F-418D-AE19-62706E023703}">
                       <ahyp:hlinkClr xmlns:ahyp="http://schemas.microsoft.com/office/drawing/2018/hyperlinkcolor" val="tx"/>
@@ -3221,22 +3175,22 @@
                   </a:extLst>
                 </a:hlinkClick>
               </a:rPr>
-              <a:t>Watch the demo</a:t>
-            </a:r>
-            <a:endParaRPr lang="en-US" sz="1600" dirty="0"/>
-          </a:p>
-        </p:txBody>
-      </p:sp>
-      <p:sp>
-        <p:nvSpPr>
-          <p:cNvPr id="9" name="Text 6"/>
-          <p:cNvSpPr txBox="1"/>
-          <p:nvPr/>
-        </p:nvSpPr>
-        <p:spPr>
-          <a:xfrm>
-            <a:off x="822960" y="4160520"/>
-            <a:ext cx="5486400" cy="731520"/>
+              <a:t>Full video with music (81 s): watch on Drive</a:t>
+            </a:r>
+            <a:endParaRPr lang="en-US" sz="1300" dirty="0"/>
+          </a:p>
+        </p:txBody>
+      </p:sp>
+      <p:sp>
+        <p:nvSpPr>
+          <p:cNvPr id="7" name="Text 4"/>
+          <p:cNvSpPr txBox="1"/>
+          <p:nvPr/>
+        </p:nvSpPr>
+        <p:spPr>
+          <a:xfrm>
+            <a:off x="548640" y="5394960"/>
+            <a:ext cx="6217920" cy="274320"/>
           </a:xfrm>
           <a:prstGeom prst="rect">
             <a:avLst/>
@@ -3252,53 +3206,14 @@
               <a:buNone/>
             </a:pPr>
             <a:r>
-              <a:rPr lang="en-US" sz="1200" dirty="0">
-                <a:solidFill>
-                  <a:srgbClr val="A3B3C9"/>
+              <a:rPr lang="en-US" sz="900" u="sng" dirty="0">
+                <a:solidFill>
+                  <a:srgbClr val="64748B"/>
                 </a:solidFill>
                 <a:latin typeface="Calibri" pitchFamily="34" charset="0"/>
                 <a:ea typeface="Calibri" pitchFamily="34" charset="-122"/>
                 <a:cs typeface="Calibri" pitchFamily="34" charset="-120"/>
-              </a:rPr>
-              <a:t>A kota shop orders from suppliers who deliver, pays in the app, confirmed by the provider  ·  a builder's job in stages</a:t>
-            </a:r>
-            <a:endParaRPr lang="en-US" sz="1200" dirty="0"/>
-          </a:p>
-        </p:txBody>
-      </p:sp>
-      <p:sp>
-        <p:nvSpPr>
-          <p:cNvPr id="10" name="Text 7"/>
-          <p:cNvSpPr txBox="1"/>
-          <p:nvPr/>
-        </p:nvSpPr>
-        <p:spPr>
-          <a:xfrm>
-            <a:off x="548640" y="5257800"/>
-            <a:ext cx="6035040" cy="274320"/>
-          </a:xfrm>
-          <a:prstGeom prst="rect">
-            <a:avLst/>
-          </a:prstGeom>
-          <a:noFill/>
-          <a:ln/>
-        </p:spPr>
-        <p:txBody>
-          <a:bodyPr wrap="square" lIns="0" tIns="0" rIns="0" bIns="0" rtlCol="0" anchor="t"/>
-          <a:lstStyle/>
-          <a:p>
-            <a:pPr algn="ctr" indent="0" marL="0">
-              <a:buNone/>
-            </a:pPr>
-            <a:r>
-              <a:rPr lang="en-US" sz="900" u="sng" dirty="0">
-                <a:solidFill>
-                  <a:srgbClr val="64748B"/>
-                </a:solidFill>
-                <a:latin typeface="Calibri" pitchFamily="34" charset="0"/>
-                <a:ea typeface="Calibri" pitchFamily="34" charset="-122"/>
-                <a:cs typeface="Calibri" pitchFamily="34" charset="-120"/>
-                <a:hlinkClick r:id="rId4" invalidUrl="" action="" tgtFrame="" tooltip="" history="1" highlightClick="0" endSnd="0">
+                <a:hlinkClick r:id="rId5" invalidUrl="" action="" tgtFrame="" tooltip="" history="1" highlightClick="0" endSnd="0">
                   <a:extLst>
                     <a:ext uri="{A12FA001-AC4F-418D-AE19-62706E023703}">
                       <ahyp:hlinkClr xmlns:ahyp="http://schemas.microsoft.com/office/drawing/2018/hyperlinkcolor" val="tx"/>
@@ -3314,226 +3229,7 @@
       </p:sp>
       <p:pic>
         <p:nvPicPr>
-          <p:cNvPr id="11" name="Image 1" descr="preencoded.png">    </p:cNvPr>
-          <p:cNvPicPr>
-            <a:picLocks noChangeAspect="1"/>
-          </p:cNvPicPr>
-          <p:nvPr/>
-        </p:nvPicPr>
-        <p:blipFill>
-          <a:blip r:embed="rId5"/>
-          <a:stretch>
-            <a:fillRect/>
-          </a:stretch>
-        </p:blipFill>
-        <p:spPr>
-          <a:xfrm>
-            <a:off x="7086600" y="914400"/>
-            <a:ext cx="1005840" cy="1005840"/>
-          </a:xfrm>
-          <a:prstGeom prst="rect">
-            <a:avLst/>
-          </a:prstGeom>
-        </p:spPr>
-      </p:pic>
-      <p:sp>
-        <p:nvSpPr>
-          <p:cNvPr id="12" name="Text 8"/>
-          <p:cNvSpPr txBox="1"/>
-          <p:nvPr/>
-        </p:nvSpPr>
-        <p:spPr>
-          <a:xfrm>
-            <a:off x="7040880" y="2103120"/>
-            <a:ext cx="4754880" cy="914400"/>
-          </a:xfrm>
-          <a:prstGeom prst="rect">
-            <a:avLst/>
-          </a:prstGeom>
-          <a:noFill/>
-          <a:ln/>
-        </p:spPr>
-        <p:txBody>
-          <a:bodyPr wrap="square" lIns="0" tIns="0" rIns="0" bIns="0" rtlCol="0" anchor="t"/>
-          <a:lstStyle/>
-          <a:p>
-            <a:pPr indent="0" marL="0">
-              <a:buNone/>
-            </a:pPr>
-            <a:r>
-              <a:rPr lang="en-US" sz="5000" b="1" dirty="0">
-                <a:solidFill>
-                  <a:srgbClr val="F8FAFC"/>
-                </a:solidFill>
-                <a:latin typeface="Georgia" pitchFamily="34" charset="0"/>
-                <a:ea typeface="Georgia" pitchFamily="34" charset="-122"/>
-                <a:cs typeface="Georgia" pitchFamily="34" charset="-120"/>
-              </a:rPr>
-              <a:t>Thank you</a:t>
-            </a:r>
-            <a:endParaRPr lang="en-US" sz="5000" dirty="0"/>
-          </a:p>
-        </p:txBody>
-      </p:sp>
-      <p:sp>
-        <p:nvSpPr>
-          <p:cNvPr id="13" name="Text 9"/>
-          <p:cNvSpPr txBox="1"/>
-          <p:nvPr/>
-        </p:nvSpPr>
-        <p:spPr>
-          <a:xfrm>
-            <a:off x="7086600" y="3063240"/>
-            <a:ext cx="4754880" cy="548640"/>
-          </a:xfrm>
-          <a:prstGeom prst="rect">
-            <a:avLst/>
-          </a:prstGeom>
-          <a:noFill/>
-          <a:ln/>
-        </p:spPr>
-        <p:txBody>
-          <a:bodyPr wrap="square" lIns="0" tIns="0" rIns="0" bIns="0" rtlCol="0" anchor="t"/>
-          <a:lstStyle/>
-          <a:p>
-            <a:pPr indent="0" marL="0">
-              <a:buNone/>
-            </a:pPr>
-            <a:r>
-              <a:rPr lang="en-US" sz="2400" i="1" dirty="0">
-                <a:solidFill>
-                  <a:srgbClr val="FBBF24"/>
-                </a:solidFill>
-                <a:latin typeface="Georgia" pitchFamily="34" charset="0"/>
-                <a:ea typeface="Georgia" pitchFamily="34" charset="-122"/>
-                <a:cs typeface="Georgia" pitchFamily="34" charset="-120"/>
-              </a:rPr>
-              <a:t>Keep it in the kasi.</a:t>
-            </a:r>
-            <a:endParaRPr lang="en-US" sz="2400" dirty="0"/>
-          </a:p>
-        </p:txBody>
-      </p:sp>
-      <p:sp>
-        <p:nvSpPr>
-          <p:cNvPr id="14" name="Text 10"/>
-          <p:cNvSpPr txBox="1"/>
-          <p:nvPr/>
-        </p:nvSpPr>
-        <p:spPr>
-          <a:xfrm>
-            <a:off x="7086600" y="3840480"/>
-            <a:ext cx="4754880" cy="411480"/>
-          </a:xfrm>
-          <a:prstGeom prst="rect">
-            <a:avLst/>
-          </a:prstGeom>
-          <a:noFill/>
-          <a:ln/>
-        </p:spPr>
-        <p:txBody>
-          <a:bodyPr wrap="square" lIns="0" tIns="0" rIns="0" bIns="0" rtlCol="0" anchor="t"/>
-          <a:lstStyle/>
-          <a:p>
-            <a:pPr indent="0" marL="0">
-              <a:buNone/>
-            </a:pPr>
-            <a:r>
-              <a:rPr lang="en-US" sz="1800" b="1" dirty="0">
-                <a:solidFill>
-                  <a:srgbClr val="34D399"/>
-                </a:solidFill>
-                <a:latin typeface="Calibri" pitchFamily="34" charset="0"/>
-                <a:ea typeface="Calibri" pitchFamily="34" charset="-122"/>
-                <a:cs typeface="Calibri" pitchFamily="34" charset="-120"/>
-              </a:rPr>
-              <a:t>R300,000  ·  6-month pilot</a:t>
-            </a:r>
-            <a:endParaRPr lang="en-US" sz="1800" dirty="0"/>
-          </a:p>
-        </p:txBody>
-      </p:sp>
-      <p:sp>
-        <p:nvSpPr>
-          <p:cNvPr id="15" name="Text 11"/>
-          <p:cNvSpPr txBox="1"/>
-          <p:nvPr/>
-        </p:nvSpPr>
-        <p:spPr>
-          <a:xfrm>
-            <a:off x="7086600" y="4297680"/>
-            <a:ext cx="4754880" cy="411480"/>
-          </a:xfrm>
-          <a:prstGeom prst="rect">
-            <a:avLst/>
-          </a:prstGeom>
-          <a:noFill/>
-          <a:ln/>
-        </p:spPr>
-        <p:txBody>
-          <a:bodyPr wrap="square" lIns="0" tIns="0" rIns="0" bIns="0" rtlCol="0" anchor="t"/>
-          <a:lstStyle/>
-          <a:p>
-            <a:pPr indent="0" marL="0">
-              <a:buNone/>
-            </a:pPr>
-            <a:r>
-              <a:rPr lang="en-US" sz="1500" dirty="0">
-                <a:solidFill>
-                  <a:srgbClr val="A3B3C9"/>
-                </a:solidFill>
-                <a:latin typeface="Calibri" pitchFamily="34" charset="0"/>
-                <a:ea typeface="Calibri" pitchFamily="34" charset="-122"/>
-                <a:cs typeface="Calibri" pitchFamily="34" charset="-120"/>
-              </a:rPr>
-              <a:t>Making informal and small businesses visible, and ready for tomorrow.</a:t>
-            </a:r>
-            <a:endParaRPr lang="en-US" sz="1500" dirty="0"/>
-          </a:p>
-        </p:txBody>
-      </p:sp>
-      <p:sp>
-        <p:nvSpPr>
-          <p:cNvPr id="16" name="Text 12"/>
-          <p:cNvSpPr txBox="1"/>
-          <p:nvPr/>
-        </p:nvSpPr>
-        <p:spPr>
-          <a:xfrm>
-            <a:off x="7086600" y="5394960"/>
-            <a:ext cx="4754880" cy="365760"/>
-          </a:xfrm>
-          <a:prstGeom prst="rect">
-            <a:avLst/>
-          </a:prstGeom>
-          <a:noFill/>
-          <a:ln/>
-        </p:spPr>
-        <p:txBody>
-          <a:bodyPr wrap="square" lIns="0" tIns="0" rIns="0" bIns="0" rtlCol="0" anchor="t"/>
-          <a:lstStyle/>
-          <a:p>
-            <a:pPr indent="0" marL="0">
-              <a:buNone/>
-            </a:pPr>
-            <a:r>
-              <a:rPr lang="en-US" sz="1400" dirty="0">
-                <a:solidFill>
-                  <a:srgbClr val="F8FAFC"/>
-                </a:solidFill>
-                <a:latin typeface="Calibri" pitchFamily="34" charset="0"/>
-                <a:ea typeface="Calibri" pitchFamily="34" charset="-122"/>
-                <a:cs typeface="Calibri" pitchFamily="34" charset="-120"/>
-              </a:rPr>
-              <a:t>Prepared by Team PR</a:t>
-            </a:r>
-            <a:endParaRPr lang="en-US" sz="1400" dirty="0"/>
-          </a:p>
-        </p:txBody>
-      </p:sp>
-      <p:pic>
-        <p:nvPicPr>
-          <p:cNvPr id="17" name="Image 2" descr="preencoded.png">    </p:cNvPr>
+          <p:cNvPr id="8" name="Image 0" descr="preencoded.png">    </p:cNvPr>
           <p:cNvPicPr>
             <a:picLocks noChangeAspect="1"/>
           </p:cNvPicPr>
@@ -3547,6 +3243,225 @@
         </p:blipFill>
         <p:spPr>
           <a:xfrm>
+            <a:off x="7086600" y="914400"/>
+            <a:ext cx="1005840" cy="1005840"/>
+          </a:xfrm>
+          <a:prstGeom prst="rect">
+            <a:avLst/>
+          </a:prstGeom>
+        </p:spPr>
+      </p:pic>
+      <p:sp>
+        <p:nvSpPr>
+          <p:cNvPr id="9" name="Text 5"/>
+          <p:cNvSpPr txBox="1"/>
+          <p:nvPr/>
+        </p:nvSpPr>
+        <p:spPr>
+          <a:xfrm>
+            <a:off x="7040880" y="2103120"/>
+            <a:ext cx="4754880" cy="914400"/>
+          </a:xfrm>
+          <a:prstGeom prst="rect">
+            <a:avLst/>
+          </a:prstGeom>
+          <a:noFill/>
+          <a:ln/>
+        </p:spPr>
+        <p:txBody>
+          <a:bodyPr wrap="square" lIns="0" tIns="0" rIns="0" bIns="0" rtlCol="0" anchor="t"/>
+          <a:lstStyle/>
+          <a:p>
+            <a:pPr indent="0" marL="0">
+              <a:buNone/>
+            </a:pPr>
+            <a:r>
+              <a:rPr lang="en-US" sz="5000" b="1" dirty="0">
+                <a:solidFill>
+                  <a:srgbClr val="F8FAFC"/>
+                </a:solidFill>
+                <a:latin typeface="Georgia" pitchFamily="34" charset="0"/>
+                <a:ea typeface="Georgia" pitchFamily="34" charset="-122"/>
+                <a:cs typeface="Georgia" pitchFamily="34" charset="-120"/>
+              </a:rPr>
+              <a:t>Thank you</a:t>
+            </a:r>
+            <a:endParaRPr lang="en-US" sz="5000" dirty="0"/>
+          </a:p>
+        </p:txBody>
+      </p:sp>
+      <p:sp>
+        <p:nvSpPr>
+          <p:cNvPr id="10" name="Text 6"/>
+          <p:cNvSpPr txBox="1"/>
+          <p:nvPr/>
+        </p:nvSpPr>
+        <p:spPr>
+          <a:xfrm>
+            <a:off x="7086600" y="3063240"/>
+            <a:ext cx="4754880" cy="548640"/>
+          </a:xfrm>
+          <a:prstGeom prst="rect">
+            <a:avLst/>
+          </a:prstGeom>
+          <a:noFill/>
+          <a:ln/>
+        </p:spPr>
+        <p:txBody>
+          <a:bodyPr wrap="square" lIns="0" tIns="0" rIns="0" bIns="0" rtlCol="0" anchor="t"/>
+          <a:lstStyle/>
+          <a:p>
+            <a:pPr indent="0" marL="0">
+              <a:buNone/>
+            </a:pPr>
+            <a:r>
+              <a:rPr lang="en-US" sz="2400" i="1" dirty="0">
+                <a:solidFill>
+                  <a:srgbClr val="FBBF24"/>
+                </a:solidFill>
+                <a:latin typeface="Georgia" pitchFamily="34" charset="0"/>
+                <a:ea typeface="Georgia" pitchFamily="34" charset="-122"/>
+                <a:cs typeface="Georgia" pitchFamily="34" charset="-120"/>
+              </a:rPr>
+              <a:t>Keep it in the kasi.</a:t>
+            </a:r>
+            <a:endParaRPr lang="en-US" sz="2400" dirty="0"/>
+          </a:p>
+        </p:txBody>
+      </p:sp>
+      <p:sp>
+        <p:nvSpPr>
+          <p:cNvPr id="11" name="Text 7"/>
+          <p:cNvSpPr txBox="1"/>
+          <p:nvPr/>
+        </p:nvSpPr>
+        <p:spPr>
+          <a:xfrm>
+            <a:off x="7086600" y="3840480"/>
+            <a:ext cx="4754880" cy="411480"/>
+          </a:xfrm>
+          <a:prstGeom prst="rect">
+            <a:avLst/>
+          </a:prstGeom>
+          <a:noFill/>
+          <a:ln/>
+        </p:spPr>
+        <p:txBody>
+          <a:bodyPr wrap="square" lIns="0" tIns="0" rIns="0" bIns="0" rtlCol="0" anchor="t"/>
+          <a:lstStyle/>
+          <a:p>
+            <a:pPr indent="0" marL="0">
+              <a:buNone/>
+            </a:pPr>
+            <a:r>
+              <a:rPr lang="en-US" sz="1800" b="1" dirty="0">
+                <a:solidFill>
+                  <a:srgbClr val="34D399"/>
+                </a:solidFill>
+                <a:latin typeface="Calibri" pitchFamily="34" charset="0"/>
+                <a:ea typeface="Calibri" pitchFamily="34" charset="-122"/>
+                <a:cs typeface="Calibri" pitchFamily="34" charset="-120"/>
+              </a:rPr>
+              <a:t>R300,000  ·  6-month pilot</a:t>
+            </a:r>
+            <a:endParaRPr lang="en-US" sz="1800" dirty="0"/>
+          </a:p>
+        </p:txBody>
+      </p:sp>
+      <p:sp>
+        <p:nvSpPr>
+          <p:cNvPr id="12" name="Text 8"/>
+          <p:cNvSpPr txBox="1"/>
+          <p:nvPr/>
+        </p:nvSpPr>
+        <p:spPr>
+          <a:xfrm>
+            <a:off x="7086600" y="4297680"/>
+            <a:ext cx="4754880" cy="411480"/>
+          </a:xfrm>
+          <a:prstGeom prst="rect">
+            <a:avLst/>
+          </a:prstGeom>
+          <a:noFill/>
+          <a:ln/>
+        </p:spPr>
+        <p:txBody>
+          <a:bodyPr wrap="square" lIns="0" tIns="0" rIns="0" bIns="0" rtlCol="0" anchor="t"/>
+          <a:lstStyle/>
+          <a:p>
+            <a:pPr indent="0" marL="0">
+              <a:buNone/>
+            </a:pPr>
+            <a:r>
+              <a:rPr lang="en-US" sz="1500" dirty="0">
+                <a:solidFill>
+                  <a:srgbClr val="A3B3C9"/>
+                </a:solidFill>
+                <a:latin typeface="Calibri" pitchFamily="34" charset="0"/>
+                <a:ea typeface="Calibri" pitchFamily="34" charset="-122"/>
+                <a:cs typeface="Calibri" pitchFamily="34" charset="-120"/>
+              </a:rPr>
+              <a:t>Making informal and small businesses visible, and ready for tomorrow.</a:t>
+            </a:r>
+            <a:endParaRPr lang="en-US" sz="1500" dirty="0"/>
+          </a:p>
+        </p:txBody>
+      </p:sp>
+      <p:sp>
+        <p:nvSpPr>
+          <p:cNvPr id="13" name="Text 9"/>
+          <p:cNvSpPr txBox="1"/>
+          <p:nvPr/>
+        </p:nvSpPr>
+        <p:spPr>
+          <a:xfrm>
+            <a:off x="7086600" y="5394960"/>
+            <a:ext cx="4754880" cy="365760"/>
+          </a:xfrm>
+          <a:prstGeom prst="rect">
+            <a:avLst/>
+          </a:prstGeom>
+          <a:noFill/>
+          <a:ln/>
+        </p:spPr>
+        <p:txBody>
+          <a:bodyPr wrap="square" lIns="0" tIns="0" rIns="0" bIns="0" rtlCol="0" anchor="t"/>
+          <a:lstStyle/>
+          <a:p>
+            <a:pPr indent="0" marL="0">
+              <a:buNone/>
+            </a:pPr>
+            <a:r>
+              <a:rPr lang="en-US" sz="1400" dirty="0">
+                <a:solidFill>
+                  <a:srgbClr val="F8FAFC"/>
+                </a:solidFill>
+                <a:latin typeface="Calibri" pitchFamily="34" charset="0"/>
+                <a:ea typeface="Calibri" pitchFamily="34" charset="-122"/>
+                <a:cs typeface="Calibri" pitchFamily="34" charset="-120"/>
+              </a:rPr>
+              <a:t>Prepared by Team PR</a:t>
+            </a:r>
+            <a:endParaRPr lang="en-US" sz="1400" dirty="0"/>
+          </a:p>
+        </p:txBody>
+      </p:sp>
+      <p:pic>
+        <p:nvPicPr>
+          <p:cNvPr id="14" name="Image 1" descr="preencoded.png">    </p:cNvPr>
+          <p:cNvPicPr>
+            <a:picLocks noChangeAspect="1"/>
+          </p:cNvPicPr>
+          <p:nvPr/>
+        </p:nvPicPr>
+        <p:blipFill>
+          <a:blip r:embed="rId7"/>
+          <a:stretch>
+            <a:fillRect/>
+          </a:stretch>
+        </p:blipFill>
+        <p:spPr>
+          <a:xfrm>
             <a:off x="11231575" y="6291072"/>
             <a:ext cx="384048" cy="384048"/>
           </a:xfrm>
@@ -3557,7 +3472,7 @@
       </p:pic>
       <p:sp>
         <p:nvSpPr>
-          <p:cNvPr id="18" name="Text 13"/>
+          <p:cNvPr id="15" name="Text 10"/>
           <p:cNvSpPr txBox="1"/>
           <p:nvPr/>
         </p:nvSpPr>

</xml_diff>